<commit_message>
add slide for PIM changes
</commit_message>
<xml_diff>
--- a/iseries-dk_2link/docs/ofs-asp-multilink-info.pptx
+++ b/iseries-dk_2link/docs/ofs-asp-multilink-info.pptx
@@ -12,7 +12,8 @@
     <p:sldId id="2147376604" r:id="rId6"/>
     <p:sldId id="2147376607" r:id="rId7"/>
     <p:sldId id="2147376605" r:id="rId8"/>
-    <p:sldId id="2147376606" r:id="rId9"/>
+    <p:sldId id="2147376609" r:id="rId9"/>
+    <p:sldId id="2147376606" r:id="rId10"/>
   </p:sldIdLst>
   <p:sldSz cx="12192000" cy="6858000"/>
   <p:notesSz cx="6858000" cy="9144000"/>
@@ -111,6 +112,11 @@
       </a:defRPr>
     </a:lvl9pPr>
   </p:defaultTextStyle>
+  <p:extLst>
+    <p:ext uri="{EFAFB233-063F-42B5-8137-9DF3F51BA10A}">
+      <p15:sldGuideLst xmlns:p15="http://schemas.microsoft.com/office/powerpoint/2012/main"/>
+    </p:ext>
+  </p:extLst>
 </p:presentation>
 </file>
 
@@ -261,7 +267,7 @@
           <a:p>
             <a:fld id="{13775746-E790-4A0C-AFAA-72E0767BC452}" type="datetimeFigureOut">
               <a:rPr lang="en-US" smtClean="0"/>
-              <a:t>1/29/2025</a:t>
+              <a:t>1/30/2025</a:t>
             </a:fld>
             <a:endParaRPr lang="en-US"/>
           </a:p>
@@ -459,7 +465,7 @@
           <a:p>
             <a:fld id="{13775746-E790-4A0C-AFAA-72E0767BC452}" type="datetimeFigureOut">
               <a:rPr lang="en-US" smtClean="0"/>
-              <a:t>1/29/2025</a:t>
+              <a:t>1/30/2025</a:t>
             </a:fld>
             <a:endParaRPr lang="en-US"/>
           </a:p>
@@ -667,7 +673,7 @@
           <a:p>
             <a:fld id="{13775746-E790-4A0C-AFAA-72E0767BC452}" type="datetimeFigureOut">
               <a:rPr lang="en-US" smtClean="0"/>
-              <a:t>1/29/2025</a:t>
+              <a:t>1/30/2025</a:t>
             </a:fld>
             <a:endParaRPr lang="en-US"/>
           </a:p>
@@ -1344,7 +1350,7 @@
           <a:p>
             <a:fld id="{13775746-E790-4A0C-AFAA-72E0767BC452}" type="datetimeFigureOut">
               <a:rPr lang="en-US" smtClean="0"/>
-              <a:t>1/29/2025</a:t>
+              <a:t>1/30/2025</a:t>
             </a:fld>
             <a:endParaRPr lang="en-US"/>
           </a:p>
@@ -1619,7 +1625,7 @@
           <a:p>
             <a:fld id="{13775746-E790-4A0C-AFAA-72E0767BC452}" type="datetimeFigureOut">
               <a:rPr lang="en-US" smtClean="0"/>
-              <a:t>1/29/2025</a:t>
+              <a:t>1/30/2025</a:t>
             </a:fld>
             <a:endParaRPr lang="en-US"/>
           </a:p>
@@ -1884,7 +1890,7 @@
           <a:p>
             <a:fld id="{13775746-E790-4A0C-AFAA-72E0767BC452}" type="datetimeFigureOut">
               <a:rPr lang="en-US" smtClean="0"/>
-              <a:t>1/29/2025</a:t>
+              <a:t>1/30/2025</a:t>
             </a:fld>
             <a:endParaRPr lang="en-US"/>
           </a:p>
@@ -2296,7 +2302,7 @@
           <a:p>
             <a:fld id="{13775746-E790-4A0C-AFAA-72E0767BC452}" type="datetimeFigureOut">
               <a:rPr lang="en-US" smtClean="0"/>
-              <a:t>1/29/2025</a:t>
+              <a:t>1/30/2025</a:t>
             </a:fld>
             <a:endParaRPr lang="en-US"/>
           </a:p>
@@ -2437,7 +2443,7 @@
           <a:p>
             <a:fld id="{13775746-E790-4A0C-AFAA-72E0767BC452}" type="datetimeFigureOut">
               <a:rPr lang="en-US" smtClean="0"/>
-              <a:t>1/29/2025</a:t>
+              <a:t>1/30/2025</a:t>
             </a:fld>
             <a:endParaRPr lang="en-US"/>
           </a:p>
@@ -2550,7 +2556,7 @@
           <a:p>
             <a:fld id="{13775746-E790-4A0C-AFAA-72E0767BC452}" type="datetimeFigureOut">
               <a:rPr lang="en-US" smtClean="0"/>
-              <a:t>1/29/2025</a:t>
+              <a:t>1/30/2025</a:t>
             </a:fld>
             <a:endParaRPr lang="en-US"/>
           </a:p>
@@ -2861,7 +2867,7 @@
           <a:p>
             <a:fld id="{13775746-E790-4A0C-AFAA-72E0767BC452}" type="datetimeFigureOut">
               <a:rPr lang="en-US" smtClean="0"/>
-              <a:t>1/29/2025</a:t>
+              <a:t>1/30/2025</a:t>
             </a:fld>
             <a:endParaRPr lang="en-US"/>
           </a:p>
@@ -3149,7 +3155,7 @@
           <a:p>
             <a:fld id="{13775746-E790-4A0C-AFAA-72E0767BC452}" type="datetimeFigureOut">
               <a:rPr lang="en-US" smtClean="0"/>
-              <a:t>1/29/2025</a:t>
+              <a:t>1/30/2025</a:t>
             </a:fld>
             <a:endParaRPr lang="en-US"/>
           </a:p>
@@ -3390,7 +3396,7 @@
           <a:p>
             <a:fld id="{13775746-E790-4A0C-AFAA-72E0767BC452}" type="datetimeFigureOut">
               <a:rPr lang="en-US" smtClean="0"/>
-              <a:t>1/29/2025</a:t>
+              <a:t>1/30/2025</a:t>
             </a:fld>
             <a:endParaRPr lang="en-US"/>
           </a:p>
@@ -4797,6 +4803,176 @@
 </file>
 
 <file path=ppt/slides/slide8.xml><?xml version="1.0" encoding="utf-8"?>
+<p:sld xmlns:a="http://schemas.openxmlformats.org/drawingml/2006/main" xmlns:r="http://schemas.openxmlformats.org/officeDocument/2006/relationships" xmlns:p="http://schemas.openxmlformats.org/presentationml/2006/main">
+  <p:cSld>
+    <p:spTree>
+      <p:nvGrpSpPr>
+        <p:cNvPr id="1" name="">
+          <a:extLst>
+            <a:ext uri="{FF2B5EF4-FFF2-40B4-BE49-F238E27FC236}">
+              <a16:creationId xmlns:a16="http://schemas.microsoft.com/office/drawing/2014/main" id="{A2DF88FE-9845-CA7D-3358-B2E145EEBA94}"/>
+            </a:ext>
+          </a:extLst>
+        </p:cNvPr>
+        <p:cNvGrpSpPr/>
+        <p:nvPr/>
+      </p:nvGrpSpPr>
+      <p:grpSpPr>
+        <a:xfrm>
+          <a:off x="0" y="0"/>
+          <a:ext cx="0" cy="0"/>
+          <a:chOff x="0" y="0"/>
+          <a:chExt cx="0" cy="0"/>
+        </a:xfrm>
+      </p:grpSpPr>
+      <p:sp>
+        <p:nvSpPr>
+          <p:cNvPr id="3" name="Title 2">
+            <a:extLst>
+              <a:ext uri="{FF2B5EF4-FFF2-40B4-BE49-F238E27FC236}">
+                <a16:creationId xmlns:a16="http://schemas.microsoft.com/office/drawing/2014/main" id="{ED34024D-598E-79B7-6B37-059905D4DB8F}"/>
+              </a:ext>
+            </a:extLst>
+          </p:cNvPr>
+          <p:cNvSpPr>
+            <a:spLocks noGrp="1"/>
+          </p:cNvSpPr>
+          <p:nvPr>
+            <p:ph type="title" idx="4294967295"/>
+          </p:nvPr>
+        </p:nvSpPr>
+        <p:spPr>
+          <a:xfrm>
+            <a:off x="280086" y="234950"/>
+            <a:ext cx="11911914" cy="1200150"/>
+          </a:xfrm>
+        </p:spPr>
+        <p:txBody>
+          <a:bodyPr/>
+          <a:lstStyle/>
+          <a:p>
+            <a:r>
+              <a:rPr lang="en-US" dirty="0"/>
+              <a:t>Changes to AXI/AVMM Conversion </a:t>
+            </a:r>
+            <a:r>
+              <a:rPr lang="en-US"/>
+              <a:t>(PIM Modules)</a:t>
+            </a:r>
+            <a:endParaRPr lang="en-US" dirty="0"/>
+          </a:p>
+        </p:txBody>
+      </p:sp>
+      <p:sp>
+        <p:nvSpPr>
+          <p:cNvPr id="4" name="Text Placeholder 3">
+            <a:extLst>
+              <a:ext uri="{FF2B5EF4-FFF2-40B4-BE49-F238E27FC236}">
+                <a16:creationId xmlns:a16="http://schemas.microsoft.com/office/drawing/2014/main" id="{0AB38191-01E7-ADCA-1EE0-899B77DEBA47}"/>
+              </a:ext>
+            </a:extLst>
+          </p:cNvPr>
+          <p:cNvSpPr>
+            <a:spLocks noGrp="1"/>
+          </p:cNvSpPr>
+          <p:nvPr>
+            <p:ph type="body" idx="4294967295"/>
+          </p:nvPr>
+        </p:nvSpPr>
+        <p:spPr>
+          <a:xfrm>
+            <a:off x="0" y="1509713"/>
+            <a:ext cx="10625138" cy="4276725"/>
+          </a:xfrm>
+        </p:spPr>
+        <p:txBody>
+          <a:bodyPr>
+            <a:normAutofit fontScale="92500"/>
+          </a:bodyPr>
+          <a:lstStyle/>
+          <a:p>
+            <a:r>
+              <a:rPr lang="en-US" dirty="0"/>
+              <a:t>The Parent link remains the same – AXI-ST[0]</a:t>
+            </a:r>
+          </a:p>
+          <a:p>
+            <a:pPr lvl="1"/>
+            <a:r>
+              <a:rPr lang="en-US" dirty="0"/>
+              <a:t>Leverages the PIM’s </a:t>
+            </a:r>
+            <a:r>
+              <a:rPr lang="en-US" dirty="0" err="1"/>
+              <a:t>ofs_plat_host_chan_as_avalon_mem_rdwr_with_mmio</a:t>
+            </a:r>
+            <a:r>
+              <a:rPr lang="en-US" dirty="0"/>
+              <a:t> module to give us the host-mem AVMM_RDWR interface and a MMIO64 AVMM interface for the ASP</a:t>
+            </a:r>
+          </a:p>
+          <a:p>
+            <a:pPr lvl="1"/>
+            <a:r>
+              <a:rPr lang="en-US" dirty="0"/>
+              <a:t>This link’s AFU ID / DFL information changes to indicate there is a child link, including the child’s GUID</a:t>
+            </a:r>
+          </a:p>
+          <a:p>
+            <a:r>
+              <a:rPr lang="en-US" dirty="0"/>
+              <a:t>The Child AXI-ST link is AXI-ST[1]</a:t>
+            </a:r>
+          </a:p>
+          <a:p>
+            <a:pPr lvl="1"/>
+            <a:r>
+              <a:rPr lang="en-US" dirty="0"/>
+              <a:t>Uses the PIM’s </a:t>
+            </a:r>
+            <a:r>
+              <a:rPr lang="en-US" dirty="0" err="1"/>
+              <a:t>ofs_plat_host_chan_fim_multi_link_afu_dfh</a:t>
+            </a:r>
+            <a:r>
+              <a:rPr lang="en-US" dirty="0"/>
+              <a:t> with the child’s GUID</a:t>
+            </a:r>
+          </a:p>
+          <a:p>
+            <a:pPr lvl="1"/>
+            <a:r>
+              <a:rPr lang="en-US" dirty="0"/>
+              <a:t>The PIM’s AXI-ST / AVMM_RDWR conversion occurs using </a:t>
+            </a:r>
+            <a:r>
+              <a:rPr lang="en-US" dirty="0" err="1"/>
+              <a:t>ofs_plat_host_chan_as_avalon_mem_rdwr</a:t>
+            </a:r>
+            <a:r>
+              <a:rPr lang="en-US" dirty="0"/>
+              <a:t>, which is similar to the parent link except it doesn’t include the MMIO AVMM interface (the only MMIO transactions handled on the child link are the DFH transactions)</a:t>
+            </a:r>
+          </a:p>
+          <a:p>
+            <a:endParaRPr lang="en-US" sz="2400" dirty="0"/>
+          </a:p>
+        </p:txBody>
+      </p:sp>
+    </p:spTree>
+    <p:extLst>
+      <p:ext uri="{BB962C8B-B14F-4D97-AF65-F5344CB8AC3E}">
+        <p14:creationId xmlns:p14="http://schemas.microsoft.com/office/powerpoint/2010/main" val="2364973407"/>
+      </p:ext>
+    </p:extLst>
+  </p:cSld>
+  <p:clrMapOvr>
+    <a:masterClrMapping/>
+  </p:clrMapOvr>
+</p:sld>
+</file>
+
+<file path=ppt/slides/slide9.xml><?xml version="1.0" encoding="utf-8"?>
 <p:sld xmlns:a="http://schemas.openxmlformats.org/drawingml/2006/main" xmlns:r="http://schemas.openxmlformats.org/officeDocument/2006/relationships" xmlns:p="http://schemas.openxmlformats.org/presentationml/2006/main">
   <p:cSld>
     <p:spTree>

</xml_diff>

<commit_message>
misc updates to ppt
</commit_message>
<xml_diff>
--- a/iseries-dk_2link/docs/ofs-asp-multilink-info.pptx
+++ b/iseries-dk_2link/docs/ofs-asp-multilink-info.pptx
@@ -9,11 +9,18 @@
     <p:sldId id="2147376591" r:id="rId3"/>
     <p:sldId id="2147376608" r:id="rId4"/>
     <p:sldId id="2147376603" r:id="rId5"/>
-    <p:sldId id="2147376604" r:id="rId6"/>
-    <p:sldId id="2147376607" r:id="rId7"/>
-    <p:sldId id="2147376605" r:id="rId8"/>
-    <p:sldId id="2147376609" r:id="rId9"/>
-    <p:sldId id="2147376606" r:id="rId10"/>
+    <p:sldId id="2147376609" r:id="rId6"/>
+    <p:sldId id="2147376605" r:id="rId7"/>
+    <p:sldId id="2147376604" r:id="rId8"/>
+    <p:sldId id="2147376607" r:id="rId9"/>
+    <p:sldId id="2147376611" r:id="rId10"/>
+    <p:sldId id="2147376612" r:id="rId11"/>
+    <p:sldId id="2147376613" r:id="rId12"/>
+    <p:sldId id="2147376614" r:id="rId13"/>
+    <p:sldId id="2147376616" r:id="rId14"/>
+    <p:sldId id="2147376615" r:id="rId15"/>
+    <p:sldId id="2147376617" r:id="rId16"/>
+    <p:sldId id="2147376606" r:id="rId17"/>
   </p:sldIdLst>
   <p:sldSz cx="12192000" cy="6858000"/>
   <p:notesSz cx="6858000" cy="9144000"/>
@@ -3910,6 +3917,2087 @@
 </p:sld>
 </file>
 
+<file path=ppt/slides/slide10.xml><?xml version="1.0" encoding="utf-8"?>
+<p:sld xmlns:a="http://schemas.openxmlformats.org/drawingml/2006/main" xmlns:r="http://schemas.openxmlformats.org/officeDocument/2006/relationships" xmlns:p="http://schemas.openxmlformats.org/presentationml/2006/main">
+  <p:cSld>
+    <p:spTree>
+      <p:nvGrpSpPr>
+        <p:cNvPr id="1" name="">
+          <a:extLst>
+            <a:ext uri="{FF2B5EF4-FFF2-40B4-BE49-F238E27FC236}">
+              <a16:creationId xmlns:a16="http://schemas.microsoft.com/office/drawing/2014/main" id="{8E48E7F8-1EAA-9118-92A3-E07E23B18D32}"/>
+            </a:ext>
+          </a:extLst>
+        </p:cNvPr>
+        <p:cNvGrpSpPr/>
+        <p:nvPr/>
+      </p:nvGrpSpPr>
+      <p:grpSpPr>
+        <a:xfrm>
+          <a:off x="0" y="0"/>
+          <a:ext cx="0" cy="0"/>
+          <a:chOff x="0" y="0"/>
+          <a:chExt cx="0" cy="0"/>
+        </a:xfrm>
+      </p:grpSpPr>
+      <p:sp>
+        <p:nvSpPr>
+          <p:cNvPr id="3" name="Title 2">
+            <a:extLst>
+              <a:ext uri="{FF2B5EF4-FFF2-40B4-BE49-F238E27FC236}">
+                <a16:creationId xmlns:a16="http://schemas.microsoft.com/office/drawing/2014/main" id="{87074BD9-F86D-F481-E704-5346985DA43B}"/>
+              </a:ext>
+            </a:extLst>
+          </p:cNvPr>
+          <p:cNvSpPr>
+            <a:spLocks noGrp="1"/>
+          </p:cNvSpPr>
+          <p:nvPr>
+            <p:ph type="title" idx="4294967295"/>
+          </p:nvPr>
+        </p:nvSpPr>
+        <p:spPr>
+          <a:xfrm>
+            <a:off x="1220788" y="234950"/>
+            <a:ext cx="10971212" cy="1200150"/>
+          </a:xfrm>
+        </p:spPr>
+        <p:txBody>
+          <a:bodyPr/>
+          <a:lstStyle/>
+          <a:p>
+            <a:r>
+              <a:rPr lang="en-US" dirty="0"/>
+              <a:t>Resource Utilization Differences</a:t>
+            </a:r>
+          </a:p>
+        </p:txBody>
+      </p:sp>
+      <p:sp>
+        <p:nvSpPr>
+          <p:cNvPr id="4" name="Text Placeholder 3">
+            <a:extLst>
+              <a:ext uri="{FF2B5EF4-FFF2-40B4-BE49-F238E27FC236}">
+                <a16:creationId xmlns:a16="http://schemas.microsoft.com/office/drawing/2014/main" id="{F0A428A9-A689-B029-1524-7320E1F1BEE1}"/>
+              </a:ext>
+            </a:extLst>
+          </p:cNvPr>
+          <p:cNvSpPr>
+            <a:spLocks noGrp="1"/>
+          </p:cNvSpPr>
+          <p:nvPr>
+            <p:ph type="body" idx="4294967295"/>
+          </p:nvPr>
+        </p:nvSpPr>
+        <p:spPr>
+          <a:xfrm>
+            <a:off x="0" y="1509713"/>
+            <a:ext cx="10625138" cy="3749675"/>
+          </a:xfrm>
+        </p:spPr>
+        <p:txBody>
+          <a:bodyPr/>
+          <a:lstStyle/>
+          <a:p>
+            <a:endParaRPr lang="en-US" sz="2400" dirty="0"/>
+          </a:p>
+        </p:txBody>
+      </p:sp>
+    </p:spTree>
+    <p:extLst>
+      <p:ext uri="{BB962C8B-B14F-4D97-AF65-F5344CB8AC3E}">
+        <p14:creationId xmlns:p14="http://schemas.microsoft.com/office/powerpoint/2010/main" val="3860093688"/>
+      </p:ext>
+    </p:extLst>
+  </p:cSld>
+  <p:clrMapOvr>
+    <a:masterClrMapping/>
+  </p:clrMapOvr>
+</p:sld>
+</file>
+
+<file path=ppt/slides/slide11.xml><?xml version="1.0" encoding="utf-8"?>
+<p:sld xmlns:a="http://schemas.openxmlformats.org/drawingml/2006/main" xmlns:r="http://schemas.openxmlformats.org/officeDocument/2006/relationships" xmlns:p="http://schemas.openxmlformats.org/presentationml/2006/main">
+  <p:cSld>
+    <p:spTree>
+      <p:nvGrpSpPr>
+        <p:cNvPr id="1" name="">
+          <a:extLst>
+            <a:ext uri="{FF2B5EF4-FFF2-40B4-BE49-F238E27FC236}">
+              <a16:creationId xmlns:a16="http://schemas.microsoft.com/office/drawing/2014/main" id="{ABA1596D-B175-6D00-124D-39E94359164E}"/>
+            </a:ext>
+          </a:extLst>
+        </p:cNvPr>
+        <p:cNvGrpSpPr/>
+        <p:nvPr/>
+      </p:nvGrpSpPr>
+      <p:grpSpPr>
+        <a:xfrm>
+          <a:off x="0" y="0"/>
+          <a:ext cx="0" cy="0"/>
+          <a:chOff x="0" y="0"/>
+          <a:chExt cx="0" cy="0"/>
+        </a:xfrm>
+      </p:grpSpPr>
+      <p:sp>
+        <p:nvSpPr>
+          <p:cNvPr id="3" name="Title 2">
+            <a:extLst>
+              <a:ext uri="{FF2B5EF4-FFF2-40B4-BE49-F238E27FC236}">
+                <a16:creationId xmlns:a16="http://schemas.microsoft.com/office/drawing/2014/main" id="{C8D69671-0FD7-BF1F-74B8-799D2CE44ACA}"/>
+              </a:ext>
+            </a:extLst>
+          </p:cNvPr>
+          <p:cNvSpPr>
+            <a:spLocks noGrp="1"/>
+          </p:cNvSpPr>
+          <p:nvPr>
+            <p:ph type="title" idx="4294967295"/>
+          </p:nvPr>
+        </p:nvSpPr>
+        <p:spPr>
+          <a:xfrm>
+            <a:off x="1220788" y="234950"/>
+            <a:ext cx="10971212" cy="1200150"/>
+          </a:xfrm>
+        </p:spPr>
+        <p:txBody>
+          <a:bodyPr/>
+          <a:lstStyle/>
+          <a:p>
+            <a:r>
+              <a:rPr lang="en-US" dirty="0"/>
+              <a:t>Things to Consider</a:t>
+            </a:r>
+          </a:p>
+        </p:txBody>
+      </p:sp>
+      <p:sp>
+        <p:nvSpPr>
+          <p:cNvPr id="4" name="Text Placeholder 3">
+            <a:extLst>
+              <a:ext uri="{FF2B5EF4-FFF2-40B4-BE49-F238E27FC236}">
+                <a16:creationId xmlns:a16="http://schemas.microsoft.com/office/drawing/2014/main" id="{9C5642EE-CD62-9160-C041-448769420CC1}"/>
+              </a:ext>
+            </a:extLst>
+          </p:cNvPr>
+          <p:cNvSpPr>
+            <a:spLocks noGrp="1"/>
+          </p:cNvSpPr>
+          <p:nvPr>
+            <p:ph type="body" idx="4294967295"/>
+          </p:nvPr>
+        </p:nvSpPr>
+        <p:spPr>
+          <a:xfrm>
+            <a:off x="0" y="1509713"/>
+            <a:ext cx="10625138" cy="4908504"/>
+          </a:xfrm>
+        </p:spPr>
+        <p:txBody>
+          <a:bodyPr>
+            <a:normAutofit lnSpcReduction="10000"/>
+          </a:bodyPr>
+          <a:lstStyle/>
+          <a:p>
+            <a:r>
+              <a:rPr lang="en-US" sz="2400" dirty="0"/>
+              <a:t>The </a:t>
+            </a:r>
+            <a:r>
+              <a:rPr lang="en-US" sz="2400" dirty="0" err="1"/>
+              <a:t>plat_ifc.host_chan.ports</a:t>
+            </a:r>
+            <a:r>
+              <a:rPr lang="en-US" sz="2400" dirty="0"/>
+              <a:t> [] indices are important</a:t>
+            </a:r>
+          </a:p>
+          <a:p>
+            <a:pPr lvl="1"/>
+            <a:r>
+              <a:rPr lang="en-US" sz="2000" dirty="0"/>
+              <a:t>With the baseline 2-link FIM the indices are [0] for parent and [3] for child.</a:t>
+            </a:r>
+          </a:p>
+          <a:p>
+            <a:pPr lvl="1"/>
+            <a:r>
+              <a:rPr lang="en-US" sz="2000" dirty="0"/>
+              <a:t>If you use the slim FIM or another PF/VF configuration, you’ll need to check which indices are valid for the 2 separate links.</a:t>
+            </a:r>
+          </a:p>
+          <a:p>
+            <a:pPr lvl="1"/>
+            <a:r>
+              <a:rPr lang="en-US" sz="2000" dirty="0"/>
+              <a:t>Ideally, you’d have some script or function to determine this and not have it hard-coded. You should probably be able to figure it out based on FIM settings</a:t>
+            </a:r>
+            <a:r>
+              <a:rPr lang="en-US" sz="2000"/>
+              <a:t>/parameters/defines.</a:t>
+            </a:r>
+            <a:endParaRPr lang="en-US" sz="2000" dirty="0"/>
+          </a:p>
+          <a:p>
+            <a:r>
+              <a:rPr lang="en-US" sz="2400" dirty="0"/>
+              <a:t>DMA controller</a:t>
+            </a:r>
+          </a:p>
+          <a:p>
+            <a:pPr lvl="1"/>
+            <a:r>
+              <a:rPr lang="en-US" sz="2000" dirty="0"/>
+              <a:t>The dispatcher splits the single transfer over both links. </a:t>
+            </a:r>
+          </a:p>
+          <a:p>
+            <a:pPr lvl="1"/>
+            <a:r>
+              <a:rPr lang="en-US" sz="2000" dirty="0"/>
+              <a:t>It also waits for completions from both links before telling the host it is done.</a:t>
+            </a:r>
+          </a:p>
+          <a:p>
+            <a:pPr lvl="1"/>
+            <a:r>
+              <a:rPr lang="en-US" sz="2000" dirty="0"/>
+              <a:t>This has been tested with several </a:t>
+            </a:r>
+            <a:r>
+              <a:rPr lang="en-US" sz="2000" dirty="0" err="1"/>
+              <a:t>oneapi</a:t>
+            </a:r>
+            <a:r>
+              <a:rPr lang="en-US" sz="2000" dirty="0"/>
+              <a:t>-samples designs in hardware, and it works so far. However, it is a drastic change from how the controller/dispatcher used to function, so, of course, it could have bugs.</a:t>
+            </a:r>
+          </a:p>
+          <a:p>
+            <a:r>
+              <a:rPr lang="en-US" sz="2400" dirty="0"/>
+              <a:t>Child GUID</a:t>
+            </a:r>
+          </a:p>
+          <a:p>
+            <a:pPr lvl="1"/>
+            <a:r>
+              <a:rPr lang="en-US" sz="2000" dirty="0"/>
+              <a:t>The child GUID must match the information in the parent’s DFH data.</a:t>
+            </a:r>
+          </a:p>
+          <a:p>
+            <a:pPr lvl="1"/>
+            <a:r>
+              <a:rPr lang="en-US" sz="2000" dirty="0"/>
+              <a:t>The child GUID cannot be 0x0</a:t>
+            </a:r>
+          </a:p>
+        </p:txBody>
+      </p:sp>
+    </p:spTree>
+    <p:extLst>
+      <p:ext uri="{BB962C8B-B14F-4D97-AF65-F5344CB8AC3E}">
+        <p14:creationId xmlns:p14="http://schemas.microsoft.com/office/powerpoint/2010/main" val="2013315901"/>
+      </p:ext>
+    </p:extLst>
+  </p:cSld>
+  <p:clrMapOvr>
+    <a:masterClrMapping/>
+  </p:clrMapOvr>
+</p:sld>
+</file>
+
+<file path=ppt/slides/slide12.xml><?xml version="1.0" encoding="utf-8"?>
+<p:sld xmlns:a="http://schemas.openxmlformats.org/drawingml/2006/main" xmlns:r="http://schemas.openxmlformats.org/officeDocument/2006/relationships" xmlns:p="http://schemas.openxmlformats.org/presentationml/2006/main">
+  <p:cSld>
+    <p:spTree>
+      <p:nvGrpSpPr>
+        <p:cNvPr id="1" name="">
+          <a:extLst>
+            <a:ext uri="{FF2B5EF4-FFF2-40B4-BE49-F238E27FC236}">
+              <a16:creationId xmlns:a16="http://schemas.microsoft.com/office/drawing/2014/main" id="{778EF070-47C4-D3EE-FA02-9DA043F84A5E}"/>
+            </a:ext>
+          </a:extLst>
+        </p:cNvPr>
+        <p:cNvGrpSpPr/>
+        <p:nvPr/>
+      </p:nvGrpSpPr>
+      <p:grpSpPr>
+        <a:xfrm>
+          <a:off x="0" y="0"/>
+          <a:ext cx="0" cy="0"/>
+          <a:chOff x="0" y="0"/>
+          <a:chExt cx="0" cy="0"/>
+        </a:xfrm>
+      </p:grpSpPr>
+      <p:sp>
+        <p:nvSpPr>
+          <p:cNvPr id="3" name="Title 2">
+            <a:extLst>
+              <a:ext uri="{FF2B5EF4-FFF2-40B4-BE49-F238E27FC236}">
+                <a16:creationId xmlns:a16="http://schemas.microsoft.com/office/drawing/2014/main" id="{D42D90CF-71BF-8E4B-61BB-7F421C92D929}"/>
+              </a:ext>
+            </a:extLst>
+          </p:cNvPr>
+          <p:cNvSpPr>
+            <a:spLocks noGrp="1"/>
+          </p:cNvSpPr>
+          <p:nvPr>
+            <p:ph type="title" idx="4294967295"/>
+          </p:nvPr>
+        </p:nvSpPr>
+        <p:spPr>
+          <a:xfrm>
+            <a:off x="1220788" y="234950"/>
+            <a:ext cx="10971212" cy="1200150"/>
+          </a:xfrm>
+        </p:spPr>
+        <p:txBody>
+          <a:bodyPr/>
+          <a:lstStyle/>
+          <a:p>
+            <a:r>
+              <a:rPr lang="en-US" dirty="0"/>
+              <a:t>In-System Setup (1)</a:t>
+            </a:r>
+          </a:p>
+        </p:txBody>
+      </p:sp>
+      <p:sp>
+        <p:nvSpPr>
+          <p:cNvPr id="4" name="Text Placeholder 3">
+            <a:extLst>
+              <a:ext uri="{FF2B5EF4-FFF2-40B4-BE49-F238E27FC236}">
+                <a16:creationId xmlns:a16="http://schemas.microsoft.com/office/drawing/2014/main" id="{AE9D49EC-6FF5-74AB-C36B-F7891A93D5F7}"/>
+              </a:ext>
+            </a:extLst>
+          </p:cNvPr>
+          <p:cNvSpPr>
+            <a:spLocks noGrp="1"/>
+          </p:cNvSpPr>
+          <p:nvPr>
+            <p:ph type="body" idx="4294967295"/>
+          </p:nvPr>
+        </p:nvSpPr>
+        <p:spPr>
+          <a:xfrm>
+            <a:off x="0" y="1509713"/>
+            <a:ext cx="10625138" cy="4908504"/>
+          </a:xfrm>
+        </p:spPr>
+        <p:txBody>
+          <a:bodyPr>
+            <a:normAutofit fontScale="92500" lnSpcReduction="20000"/>
+          </a:bodyPr>
+          <a:lstStyle/>
+          <a:p>
+            <a:r>
+              <a:rPr lang="en-US" sz="2000" dirty="0"/>
+              <a:t>For a baseline FIM with a 2 x Gen5x8 interface to the host these are the initialization steps I use on our test system:</a:t>
+            </a:r>
+          </a:p>
+          <a:p>
+            <a:pPr marL="0" marR="0" indent="0">
+              <a:buNone/>
+            </a:pPr>
+            <a:r>
+              <a:rPr lang="en-US" sz="1800" dirty="0">
+                <a:effectLst/>
+                <a:latin typeface="Calibri" panose="020F0502020204030204" pitchFamily="34" charset="0"/>
+              </a:rPr>
+              <a:t> </a:t>
+            </a:r>
+          </a:p>
+          <a:p>
+            <a:pPr marL="0" marR="0" indent="0">
+              <a:buNone/>
+            </a:pPr>
+            <a:r>
+              <a:rPr lang="en-US" sz="1800" dirty="0" err="1">
+                <a:effectLst/>
+                <a:latin typeface="Calibri" panose="020F0502020204030204" pitchFamily="34" charset="0"/>
+              </a:rPr>
+              <a:t>sudo</a:t>
+            </a:r>
+            <a:r>
+              <a:rPr lang="en-US" sz="1800" dirty="0">
+                <a:effectLst/>
+                <a:latin typeface="Calibri" panose="020F0502020204030204" pitchFamily="34" charset="0"/>
+              </a:rPr>
+              <a:t> opae.io ls</a:t>
+            </a:r>
+          </a:p>
+          <a:p>
+            <a:pPr marL="0" marR="0" indent="0">
+              <a:buNone/>
+            </a:pPr>
+            <a:r>
+              <a:rPr lang="en-US" sz="1800" dirty="0" err="1">
+                <a:effectLst/>
+                <a:latin typeface="Calibri" panose="020F0502020204030204" pitchFamily="34" charset="0"/>
+              </a:rPr>
+              <a:t>sudo</a:t>
+            </a:r>
+            <a:r>
+              <a:rPr lang="en-US" sz="1800" dirty="0">
+                <a:effectLst/>
+                <a:latin typeface="Calibri" panose="020F0502020204030204" pitchFamily="34" charset="0"/>
+              </a:rPr>
+              <a:t> </a:t>
+            </a:r>
+            <a:r>
+              <a:rPr lang="en-US" sz="1800" dirty="0" err="1">
+                <a:effectLst/>
+                <a:latin typeface="Calibri" panose="020F0502020204030204" pitchFamily="34" charset="0"/>
+              </a:rPr>
+              <a:t>pci_device</a:t>
+            </a:r>
+            <a:r>
+              <a:rPr lang="en-US" sz="1800" dirty="0">
+                <a:effectLst/>
+                <a:latin typeface="Calibri" panose="020F0502020204030204" pitchFamily="34" charset="0"/>
+              </a:rPr>
+              <a:t>  0000:2a:00.0 </a:t>
+            </a:r>
+            <a:r>
+              <a:rPr lang="en-US" sz="1800" dirty="0" err="1">
+                <a:effectLst/>
+                <a:latin typeface="Calibri" panose="020F0502020204030204" pitchFamily="34" charset="0"/>
+              </a:rPr>
+              <a:t>vf</a:t>
+            </a:r>
+            <a:r>
+              <a:rPr lang="en-US" sz="1800" dirty="0">
+                <a:effectLst/>
+                <a:latin typeface="Calibri" panose="020F0502020204030204" pitchFamily="34" charset="0"/>
+              </a:rPr>
+              <a:t> 1</a:t>
+            </a:r>
+          </a:p>
+          <a:p>
+            <a:pPr marL="0" marR="0" indent="0">
+              <a:buNone/>
+            </a:pPr>
+            <a:r>
+              <a:rPr lang="en-US" sz="1800" dirty="0" err="1">
+                <a:effectLst/>
+                <a:latin typeface="Calibri" panose="020F0502020204030204" pitchFamily="34" charset="0"/>
+              </a:rPr>
+              <a:t>sudo</a:t>
+            </a:r>
+            <a:r>
+              <a:rPr lang="en-US" sz="1800" dirty="0">
+                <a:effectLst/>
+                <a:latin typeface="Calibri" panose="020F0502020204030204" pitchFamily="34" charset="0"/>
+              </a:rPr>
+              <a:t> </a:t>
+            </a:r>
+            <a:r>
+              <a:rPr lang="en-US" sz="1800" dirty="0" err="1">
+                <a:effectLst/>
+                <a:latin typeface="Calibri" panose="020F0502020204030204" pitchFamily="34" charset="0"/>
+              </a:rPr>
+              <a:t>pci_device</a:t>
+            </a:r>
+            <a:r>
+              <a:rPr lang="en-US" sz="1800" dirty="0">
+                <a:effectLst/>
+                <a:latin typeface="Calibri" panose="020F0502020204030204" pitchFamily="34" charset="0"/>
+              </a:rPr>
+              <a:t>  0000:2b:00.0 </a:t>
+            </a:r>
+            <a:r>
+              <a:rPr lang="en-US" sz="1800" dirty="0" err="1">
+                <a:effectLst/>
+                <a:latin typeface="Calibri" panose="020F0502020204030204" pitchFamily="34" charset="0"/>
+              </a:rPr>
+              <a:t>vf</a:t>
+            </a:r>
+            <a:r>
+              <a:rPr lang="en-US" sz="1800" dirty="0">
+                <a:effectLst/>
+                <a:latin typeface="Calibri" panose="020F0502020204030204" pitchFamily="34" charset="0"/>
+              </a:rPr>
+              <a:t> 1</a:t>
+            </a:r>
+          </a:p>
+          <a:p>
+            <a:pPr marL="0" marR="0" indent="0">
+              <a:buNone/>
+            </a:pPr>
+            <a:r>
+              <a:rPr lang="en-US" sz="1800" dirty="0" err="1">
+                <a:effectLst/>
+                <a:latin typeface="Calibri" panose="020F0502020204030204" pitchFamily="34" charset="0"/>
+              </a:rPr>
+              <a:t>sudo</a:t>
+            </a:r>
+            <a:r>
+              <a:rPr lang="en-US" sz="1800" dirty="0">
+                <a:effectLst/>
+                <a:latin typeface="Calibri" panose="020F0502020204030204" pitchFamily="34" charset="0"/>
+              </a:rPr>
+              <a:t> opae.io ls</a:t>
+            </a:r>
+          </a:p>
+          <a:p>
+            <a:pPr marL="0" marR="0" indent="0">
+              <a:buNone/>
+            </a:pPr>
+            <a:r>
+              <a:rPr lang="en-US" sz="1800" dirty="0" err="1">
+                <a:effectLst/>
+                <a:latin typeface="Calibri" panose="020F0502020204030204" pitchFamily="34" charset="0"/>
+              </a:rPr>
+              <a:t>sudo</a:t>
+            </a:r>
+            <a:r>
+              <a:rPr lang="en-US" sz="1800" dirty="0">
+                <a:effectLst/>
+                <a:latin typeface="Calibri" panose="020F0502020204030204" pitchFamily="34" charset="0"/>
+              </a:rPr>
+              <a:t> opae.io </a:t>
+            </a:r>
+            <a:r>
+              <a:rPr lang="en-US" sz="1800" dirty="0" err="1">
+                <a:effectLst/>
+                <a:latin typeface="Calibri" panose="020F0502020204030204" pitchFamily="34" charset="0"/>
+              </a:rPr>
+              <a:t>init</a:t>
+            </a:r>
+            <a:r>
+              <a:rPr lang="en-US" sz="1800" dirty="0">
+                <a:effectLst/>
+                <a:latin typeface="Calibri" panose="020F0502020204030204" pitchFamily="34" charset="0"/>
+              </a:rPr>
+              <a:t> -d 0000:2a:00.3 </a:t>
+            </a:r>
+            <a:r>
+              <a:rPr lang="en-US" sz="1800" dirty="0" err="1">
+                <a:effectLst/>
+                <a:latin typeface="Calibri" panose="020F0502020204030204" pitchFamily="34" charset="0"/>
+              </a:rPr>
+              <a:t>user:user</a:t>
+            </a:r>
+            <a:endParaRPr lang="en-US" sz="1800" dirty="0">
+              <a:effectLst/>
+              <a:latin typeface="Calibri" panose="020F0502020204030204" pitchFamily="34" charset="0"/>
+            </a:endParaRPr>
+          </a:p>
+          <a:p>
+            <a:pPr marL="0" marR="0" indent="0">
+              <a:buNone/>
+            </a:pPr>
+            <a:r>
+              <a:rPr lang="en-US" sz="1800" dirty="0" err="1">
+                <a:effectLst/>
+                <a:latin typeface="Calibri" panose="020F0502020204030204" pitchFamily="34" charset="0"/>
+              </a:rPr>
+              <a:t>sudo</a:t>
+            </a:r>
+            <a:r>
+              <a:rPr lang="en-US" sz="1800" dirty="0">
+                <a:effectLst/>
+                <a:latin typeface="Calibri" panose="020F0502020204030204" pitchFamily="34" charset="0"/>
+              </a:rPr>
+              <a:t> opae.io </a:t>
+            </a:r>
+            <a:r>
+              <a:rPr lang="en-US" sz="1800" dirty="0" err="1">
+                <a:effectLst/>
+                <a:latin typeface="Calibri" panose="020F0502020204030204" pitchFamily="34" charset="0"/>
+              </a:rPr>
+              <a:t>init</a:t>
+            </a:r>
+            <a:r>
+              <a:rPr lang="en-US" sz="1800" dirty="0">
+                <a:effectLst/>
+                <a:latin typeface="Calibri" panose="020F0502020204030204" pitchFamily="34" charset="0"/>
+              </a:rPr>
+              <a:t> -d 0000:2b:00.3 </a:t>
+            </a:r>
+            <a:r>
+              <a:rPr lang="en-US" sz="1800" dirty="0" err="1">
+                <a:effectLst/>
+                <a:latin typeface="Calibri" panose="020F0502020204030204" pitchFamily="34" charset="0"/>
+              </a:rPr>
+              <a:t>user:user</a:t>
+            </a:r>
+            <a:endParaRPr lang="en-US" sz="1800" dirty="0">
+              <a:effectLst/>
+              <a:latin typeface="Calibri" panose="020F0502020204030204" pitchFamily="34" charset="0"/>
+            </a:endParaRPr>
+          </a:p>
+          <a:p>
+            <a:pPr marL="0" marR="0" indent="0">
+              <a:buNone/>
+            </a:pPr>
+            <a:r>
+              <a:rPr lang="en-US" sz="1800" dirty="0" err="1">
+                <a:effectLst/>
+                <a:latin typeface="Calibri" panose="020F0502020204030204" pitchFamily="34" charset="0"/>
+              </a:rPr>
+              <a:t>sudo</a:t>
+            </a:r>
+            <a:r>
+              <a:rPr lang="en-US" sz="1800" dirty="0">
+                <a:effectLst/>
+                <a:latin typeface="Calibri" panose="020F0502020204030204" pitchFamily="34" charset="0"/>
+              </a:rPr>
+              <a:t> opae.io ls</a:t>
+            </a:r>
+          </a:p>
+          <a:p>
+            <a:pPr marL="0" marR="0" indent="0">
+              <a:buNone/>
+            </a:pPr>
+            <a:r>
+              <a:rPr lang="en-US" sz="1800" dirty="0" err="1">
+                <a:effectLst/>
+                <a:latin typeface="Calibri" panose="020F0502020204030204" pitchFamily="34" charset="0"/>
+              </a:rPr>
+              <a:t>lspci</a:t>
+            </a:r>
+            <a:r>
+              <a:rPr lang="en-US" sz="1800" dirty="0">
+                <a:effectLst/>
+                <a:latin typeface="Calibri" panose="020F0502020204030204" pitchFamily="34" charset="0"/>
+              </a:rPr>
+              <a:t> | grep accel</a:t>
+            </a:r>
+          </a:p>
+          <a:p>
+            <a:pPr marL="0" marR="0" indent="0">
+              <a:buNone/>
+            </a:pPr>
+            <a:r>
+              <a:rPr lang="en-US" sz="1800" dirty="0">
+                <a:effectLst/>
+                <a:latin typeface="Calibri" panose="020F0502020204030204" pitchFamily="34" charset="0"/>
+              </a:rPr>
+              <a:t>export ACL_HAL_DEBUG=99</a:t>
+            </a:r>
+          </a:p>
+          <a:p>
+            <a:pPr marL="0" marR="0" indent="0">
+              <a:buNone/>
+            </a:pPr>
+            <a:r>
+              <a:rPr lang="en-US" sz="1800" dirty="0">
+                <a:effectLst/>
+                <a:latin typeface="Calibri" panose="020F0502020204030204" pitchFamily="34" charset="0"/>
+              </a:rPr>
+              <a:t>#debugging messages from mmd</a:t>
+            </a:r>
+          </a:p>
+          <a:p>
+            <a:pPr marL="0" marR="0" indent="0">
+              <a:buNone/>
+            </a:pPr>
+            <a:r>
+              <a:rPr lang="en-US" sz="1800" dirty="0">
+                <a:effectLst/>
+                <a:latin typeface="Calibri" panose="020F0502020204030204" pitchFamily="34" charset="0"/>
+              </a:rPr>
+              <a:t>export MMD_ENABLE_DEBUG=1</a:t>
+            </a:r>
+          </a:p>
+          <a:p>
+            <a:pPr marL="0" marR="0" indent="0">
+              <a:buNone/>
+            </a:pPr>
+            <a:r>
+              <a:rPr lang="en-US" sz="1800" dirty="0">
+                <a:effectLst/>
+                <a:latin typeface="Calibri" panose="020F0502020204030204" pitchFamily="34" charset="0"/>
+              </a:rPr>
+              <a:t>export MMD_DMA_DEBUG=1</a:t>
+            </a:r>
+          </a:p>
+          <a:p>
+            <a:pPr marL="0" marR="0" indent="0">
+              <a:buNone/>
+            </a:pPr>
+            <a:r>
+              <a:rPr lang="en-US" sz="1800" dirty="0">
+                <a:effectLst/>
+                <a:latin typeface="Calibri" panose="020F0502020204030204" pitchFamily="34" charset="0"/>
+              </a:rPr>
+              <a:t>export LIBOPAE_LOG=2</a:t>
+            </a:r>
+          </a:p>
+          <a:p>
+            <a:endParaRPr lang="en-US" sz="2000" dirty="0"/>
+          </a:p>
+        </p:txBody>
+      </p:sp>
+    </p:spTree>
+    <p:extLst>
+      <p:ext uri="{BB962C8B-B14F-4D97-AF65-F5344CB8AC3E}">
+        <p14:creationId xmlns:p14="http://schemas.microsoft.com/office/powerpoint/2010/main" val="1098193374"/>
+      </p:ext>
+    </p:extLst>
+  </p:cSld>
+  <p:clrMapOvr>
+    <a:masterClrMapping/>
+  </p:clrMapOvr>
+</p:sld>
+</file>
+
+<file path=ppt/slides/slide13.xml><?xml version="1.0" encoding="utf-8"?>
+<p:sld xmlns:a="http://schemas.openxmlformats.org/drawingml/2006/main" xmlns:r="http://schemas.openxmlformats.org/officeDocument/2006/relationships" xmlns:p="http://schemas.openxmlformats.org/presentationml/2006/main">
+  <p:cSld>
+    <p:spTree>
+      <p:nvGrpSpPr>
+        <p:cNvPr id="1" name="">
+          <a:extLst>
+            <a:ext uri="{FF2B5EF4-FFF2-40B4-BE49-F238E27FC236}">
+              <a16:creationId xmlns:a16="http://schemas.microsoft.com/office/drawing/2014/main" id="{5455A7C1-4D29-780F-6125-0EA3C7FBD06E}"/>
+            </a:ext>
+          </a:extLst>
+        </p:cNvPr>
+        <p:cNvGrpSpPr/>
+        <p:nvPr/>
+      </p:nvGrpSpPr>
+      <p:grpSpPr>
+        <a:xfrm>
+          <a:off x="0" y="0"/>
+          <a:ext cx="0" cy="0"/>
+          <a:chOff x="0" y="0"/>
+          <a:chExt cx="0" cy="0"/>
+        </a:xfrm>
+      </p:grpSpPr>
+      <p:sp>
+        <p:nvSpPr>
+          <p:cNvPr id="3" name="Title 2">
+            <a:extLst>
+              <a:ext uri="{FF2B5EF4-FFF2-40B4-BE49-F238E27FC236}">
+                <a16:creationId xmlns:a16="http://schemas.microsoft.com/office/drawing/2014/main" id="{756EF4CB-74DB-00C5-3908-23F1E00B1489}"/>
+              </a:ext>
+            </a:extLst>
+          </p:cNvPr>
+          <p:cNvSpPr>
+            <a:spLocks noGrp="1"/>
+          </p:cNvSpPr>
+          <p:nvPr>
+            <p:ph type="title" idx="4294967295"/>
+          </p:nvPr>
+        </p:nvSpPr>
+        <p:spPr>
+          <a:xfrm>
+            <a:off x="1220788" y="234950"/>
+            <a:ext cx="10971212" cy="1200150"/>
+          </a:xfrm>
+        </p:spPr>
+        <p:txBody>
+          <a:bodyPr/>
+          <a:lstStyle/>
+          <a:p>
+            <a:r>
+              <a:rPr lang="en-US" dirty="0"/>
+              <a:t>In-System Setup (2)</a:t>
+            </a:r>
+          </a:p>
+        </p:txBody>
+      </p:sp>
+      <p:sp>
+        <p:nvSpPr>
+          <p:cNvPr id="4" name="Text Placeholder 3">
+            <a:extLst>
+              <a:ext uri="{FF2B5EF4-FFF2-40B4-BE49-F238E27FC236}">
+                <a16:creationId xmlns:a16="http://schemas.microsoft.com/office/drawing/2014/main" id="{0C5A1A93-F25F-D09C-D3C0-369E29B7C0C0}"/>
+              </a:ext>
+            </a:extLst>
+          </p:cNvPr>
+          <p:cNvSpPr>
+            <a:spLocks noGrp="1"/>
+          </p:cNvSpPr>
+          <p:nvPr>
+            <p:ph type="body" idx="4294967295"/>
+          </p:nvPr>
+        </p:nvSpPr>
+        <p:spPr>
+          <a:xfrm>
+            <a:off x="0" y="1509713"/>
+            <a:ext cx="10625138" cy="4908504"/>
+          </a:xfrm>
+        </p:spPr>
+        <p:txBody>
+          <a:bodyPr>
+            <a:normAutofit fontScale="55000" lnSpcReduction="20000"/>
+          </a:bodyPr>
+          <a:lstStyle/>
+          <a:p>
+            <a:pPr marL="0" indent="0">
+              <a:buNone/>
+            </a:pPr>
+            <a:r>
+              <a:rPr lang="en-US" sz="2000" dirty="0"/>
+              <a:t> This is the output from my test-system for the above steps:</a:t>
+            </a:r>
+          </a:p>
+          <a:p>
+            <a:pPr marL="0" indent="0">
+              <a:buNone/>
+            </a:pPr>
+            <a:r>
+              <a:rPr lang="en-US" sz="2000" dirty="0"/>
+              <a:t> </a:t>
+            </a:r>
+          </a:p>
+          <a:p>
+            <a:pPr marL="0" indent="0">
+              <a:buNone/>
+            </a:pPr>
+            <a:r>
+              <a:rPr lang="en-US" sz="2000" dirty="0"/>
+              <a:t>$ </a:t>
+            </a:r>
+            <a:r>
+              <a:rPr lang="en-US" sz="2000" dirty="0" err="1"/>
+              <a:t>sudo</a:t>
+            </a:r>
+            <a:r>
+              <a:rPr lang="en-US" sz="2000" dirty="0"/>
+              <a:t> opae.io ls</a:t>
+            </a:r>
+          </a:p>
+          <a:p>
+            <a:pPr marL="0" indent="0">
+              <a:buNone/>
+            </a:pPr>
+            <a:r>
+              <a:rPr lang="en-US" sz="2000" dirty="0"/>
+              <a:t>[0000:2b:00.1] (0x8086:0xbcce 0x8086:0x0001) Intel Acceleration JTAG PCI Development Kit (Driver: </a:t>
+            </a:r>
+            <a:r>
+              <a:rPr lang="en-US" sz="2000" dirty="0" err="1"/>
+              <a:t>dfl-pci</a:t>
+            </a:r>
+            <a:r>
+              <a:rPr lang="en-US" sz="2000" dirty="0"/>
+              <a:t>)</a:t>
+            </a:r>
+          </a:p>
+          <a:p>
+            <a:pPr marL="0" indent="0">
+              <a:buNone/>
+            </a:pPr>
+            <a:r>
+              <a:rPr lang="en-US" sz="2000" dirty="0"/>
+              <a:t>[0000:2a:00.1] (0x8086:0xbcce 0x8086:0x0001) Intel Acceleration JTAG PCI Development Kit (Driver: </a:t>
+            </a:r>
+            <a:r>
+              <a:rPr lang="en-US" sz="2000" dirty="0" err="1"/>
+              <a:t>dfl-pci</a:t>
+            </a:r>
+            <a:r>
+              <a:rPr lang="en-US" sz="2000" dirty="0"/>
+              <a:t>)</a:t>
+            </a:r>
+          </a:p>
+          <a:p>
+            <a:pPr marL="0" indent="0">
+              <a:buNone/>
+            </a:pPr>
+            <a:r>
+              <a:rPr lang="en-US" sz="2000" dirty="0"/>
+              <a:t>[0000:2b:00.2] (0x8086:0xbcce 0x8086:0x0001) Intel Acceleration JTAG PCI Development Kit (Driver: </a:t>
+            </a:r>
+            <a:r>
+              <a:rPr lang="en-US" sz="2000" dirty="0" err="1"/>
+              <a:t>dfl-pci</a:t>
+            </a:r>
+            <a:r>
+              <a:rPr lang="en-US" sz="2000" dirty="0"/>
+              <a:t>)</a:t>
+            </a:r>
+          </a:p>
+          <a:p>
+            <a:pPr marL="0" indent="0">
+              <a:buNone/>
+            </a:pPr>
+            <a:r>
+              <a:rPr lang="en-US" sz="2000" dirty="0"/>
+              <a:t>[0000:2b:00.0] (0x8086:0xbcce 0x8086:0x0001) Intel Acceleration JTAG PCI Development Kit (Driver: </a:t>
+            </a:r>
+            <a:r>
+              <a:rPr lang="en-US" sz="2000" dirty="0" err="1"/>
+              <a:t>dfl-pci</a:t>
+            </a:r>
+            <a:r>
+              <a:rPr lang="en-US" sz="2000" dirty="0"/>
+              <a:t>)</a:t>
+            </a:r>
+          </a:p>
+          <a:p>
+            <a:pPr marL="0" indent="0">
+              <a:buNone/>
+            </a:pPr>
+            <a:r>
+              <a:rPr lang="en-US" sz="2000" dirty="0"/>
+              <a:t>[0000:2a:00.2] (0x8086:0xbcce 0x8086:0x0001) Intel Acceleration JTAG PCI Development Kit (Driver: </a:t>
+            </a:r>
+            <a:r>
+              <a:rPr lang="en-US" sz="2000" dirty="0" err="1"/>
+              <a:t>dfl-pci</a:t>
+            </a:r>
+            <a:r>
+              <a:rPr lang="en-US" sz="2000" dirty="0"/>
+              <a:t>)</a:t>
+            </a:r>
+          </a:p>
+          <a:p>
+            <a:pPr marL="0" indent="0">
+              <a:buNone/>
+            </a:pPr>
+            <a:r>
+              <a:rPr lang="en-US" sz="2000" dirty="0"/>
+              <a:t>[0000:2a:00.0] (0x8086:0xbcce 0x8086:0x0001) Intel Acceleration JTAG PCI Development Kit (Driver: </a:t>
+            </a:r>
+            <a:r>
+              <a:rPr lang="en-US" sz="2000" dirty="0" err="1"/>
+              <a:t>dfl-pci</a:t>
+            </a:r>
+            <a:r>
+              <a:rPr lang="en-US" sz="2000" dirty="0"/>
+              <a:t>)</a:t>
+            </a:r>
+          </a:p>
+          <a:p>
+            <a:pPr marL="0" indent="0">
+              <a:buNone/>
+            </a:pPr>
+            <a:r>
+              <a:rPr lang="en-US" sz="2000" dirty="0"/>
+              <a:t>$ </a:t>
+            </a:r>
+            <a:r>
+              <a:rPr lang="en-US" sz="2000" dirty="0" err="1"/>
+              <a:t>sudo</a:t>
+            </a:r>
+            <a:r>
+              <a:rPr lang="en-US" sz="2000" dirty="0"/>
+              <a:t> </a:t>
+            </a:r>
+            <a:r>
+              <a:rPr lang="en-US" sz="2000" dirty="0" err="1"/>
+              <a:t>pci_device</a:t>
+            </a:r>
+            <a:r>
+              <a:rPr lang="en-US" sz="2000" dirty="0"/>
+              <a:t>  0000:2a:00.0 </a:t>
+            </a:r>
+            <a:r>
+              <a:rPr lang="en-US" sz="2000" dirty="0" err="1"/>
+              <a:t>vf</a:t>
+            </a:r>
+            <a:r>
+              <a:rPr lang="en-US" sz="2000" dirty="0"/>
+              <a:t> 1</a:t>
+            </a:r>
+          </a:p>
+          <a:p>
+            <a:pPr marL="0" indent="0">
+              <a:buNone/>
+            </a:pPr>
+            <a:r>
+              <a:rPr lang="en-US" sz="2000" dirty="0"/>
+              <a:t>$ </a:t>
+            </a:r>
+            <a:r>
+              <a:rPr lang="en-US" sz="2000" dirty="0" err="1"/>
+              <a:t>sudo</a:t>
+            </a:r>
+            <a:r>
+              <a:rPr lang="en-US" sz="2000" dirty="0"/>
+              <a:t> </a:t>
+            </a:r>
+            <a:r>
+              <a:rPr lang="en-US" sz="2000" dirty="0" err="1"/>
+              <a:t>pci_device</a:t>
+            </a:r>
+            <a:r>
+              <a:rPr lang="en-US" sz="2000" dirty="0"/>
+              <a:t>  0000:2b:00.0 </a:t>
+            </a:r>
+            <a:r>
+              <a:rPr lang="en-US" sz="2000" dirty="0" err="1"/>
+              <a:t>vf</a:t>
+            </a:r>
+            <a:r>
+              <a:rPr lang="en-US" sz="2000" dirty="0"/>
+              <a:t> 1</a:t>
+            </a:r>
+          </a:p>
+          <a:p>
+            <a:pPr marL="0" indent="0">
+              <a:buNone/>
+            </a:pPr>
+            <a:r>
+              <a:rPr lang="en-US" sz="2000" dirty="0"/>
+              <a:t>$ </a:t>
+            </a:r>
+            <a:r>
+              <a:rPr lang="en-US" sz="2000" dirty="0" err="1"/>
+              <a:t>sudo</a:t>
+            </a:r>
+            <a:r>
+              <a:rPr lang="en-US" sz="2000" dirty="0"/>
+              <a:t> opae.io ls</a:t>
+            </a:r>
+          </a:p>
+          <a:p>
+            <a:pPr marL="0" indent="0">
+              <a:buNone/>
+            </a:pPr>
+            <a:r>
+              <a:rPr lang="en-US" sz="2000" dirty="0"/>
+              <a:t>[0000:2b:00.3] (0x8086:0xbccf 0x8086:0x0001) Intel Acceleration JTAG PCI Development Kit (Driver: </a:t>
+            </a:r>
+            <a:r>
+              <a:rPr lang="en-US" sz="2000" dirty="0" err="1"/>
+              <a:t>dfl-pci</a:t>
+            </a:r>
+            <a:r>
+              <a:rPr lang="en-US" sz="2000" dirty="0"/>
+              <a:t>)</a:t>
+            </a:r>
+          </a:p>
+          <a:p>
+            <a:pPr marL="0" indent="0">
+              <a:buNone/>
+            </a:pPr>
+            <a:r>
+              <a:rPr lang="en-US" sz="2000" dirty="0"/>
+              <a:t>[0000:2b:00.1] (0x8086:0xbcce 0x8086:0x0001) Intel Acceleration JTAG PCI Development Kit (Driver: </a:t>
+            </a:r>
+            <a:r>
+              <a:rPr lang="en-US" sz="2000" dirty="0" err="1"/>
+              <a:t>dfl-pci</a:t>
+            </a:r>
+            <a:r>
+              <a:rPr lang="en-US" sz="2000" dirty="0"/>
+              <a:t>)</a:t>
+            </a:r>
+          </a:p>
+          <a:p>
+            <a:pPr marL="0" indent="0">
+              <a:buNone/>
+            </a:pPr>
+            <a:r>
+              <a:rPr lang="en-US" sz="2000" dirty="0"/>
+              <a:t>[0000:2a:00.3] (0x8086:0xbccf 0x8086:0x0001) Intel Acceleration JTAG PCI Development Kit (Driver: </a:t>
+            </a:r>
+            <a:r>
+              <a:rPr lang="en-US" sz="2000" dirty="0" err="1"/>
+              <a:t>dfl-pci</a:t>
+            </a:r>
+            <a:r>
+              <a:rPr lang="en-US" sz="2000" dirty="0"/>
+              <a:t>)</a:t>
+            </a:r>
+          </a:p>
+          <a:p>
+            <a:pPr marL="0" indent="0">
+              <a:buNone/>
+            </a:pPr>
+            <a:r>
+              <a:rPr lang="en-US" sz="2000" dirty="0"/>
+              <a:t>[0000:2a:00.1] (0x8086:0xbcce 0x8086:0x0001) Intel Acceleration JTAG PCI Development Kit (Driver: </a:t>
+            </a:r>
+            <a:r>
+              <a:rPr lang="en-US" sz="2000" dirty="0" err="1"/>
+              <a:t>dfl-pci</a:t>
+            </a:r>
+            <a:r>
+              <a:rPr lang="en-US" sz="2000" dirty="0"/>
+              <a:t>)</a:t>
+            </a:r>
+          </a:p>
+          <a:p>
+            <a:pPr marL="0" indent="0">
+              <a:buNone/>
+            </a:pPr>
+            <a:r>
+              <a:rPr lang="en-US" sz="2000" dirty="0"/>
+              <a:t>[0000:2b:00.2] (0x8086:0xbcce 0x8086:0x0001) Intel Acceleration JTAG PCI Development Kit (Driver: </a:t>
+            </a:r>
+            <a:r>
+              <a:rPr lang="en-US" sz="2000" dirty="0" err="1"/>
+              <a:t>dfl-pci</a:t>
+            </a:r>
+            <a:r>
+              <a:rPr lang="en-US" sz="2000" dirty="0"/>
+              <a:t>)</a:t>
+            </a:r>
+          </a:p>
+          <a:p>
+            <a:pPr marL="0" indent="0">
+              <a:buNone/>
+            </a:pPr>
+            <a:r>
+              <a:rPr lang="en-US" sz="2000" dirty="0"/>
+              <a:t>[0000:2b:00.0] (0x8086:0xbcce 0x8086:0x0001) Intel Acceleration JTAG PCI Development Kit (Driver: </a:t>
+            </a:r>
+            <a:r>
+              <a:rPr lang="en-US" sz="2000" dirty="0" err="1"/>
+              <a:t>dfl-pci</a:t>
+            </a:r>
+            <a:r>
+              <a:rPr lang="en-US" sz="2000" dirty="0"/>
+              <a:t>)</a:t>
+            </a:r>
+          </a:p>
+          <a:p>
+            <a:pPr marL="0" indent="0">
+              <a:buNone/>
+            </a:pPr>
+            <a:r>
+              <a:rPr lang="en-US" sz="2000" dirty="0"/>
+              <a:t>[0000:2a:00.2] (0x8086:0xbcce 0x8086:0x0001) Intel Acceleration JTAG PCI Development Kit (Driver: </a:t>
+            </a:r>
+            <a:r>
+              <a:rPr lang="en-US" sz="2000" dirty="0" err="1"/>
+              <a:t>dfl-pci</a:t>
+            </a:r>
+            <a:r>
+              <a:rPr lang="en-US" sz="2000" dirty="0"/>
+              <a:t>)</a:t>
+            </a:r>
+          </a:p>
+          <a:p>
+            <a:pPr marL="0" indent="0">
+              <a:buNone/>
+            </a:pPr>
+            <a:r>
+              <a:rPr lang="en-US" sz="2000" dirty="0"/>
+              <a:t>[0000:2a:00.0] (0x8086:0xbcce 0x8086:0x0001) Intel Acceleration JTAG PCI Development Kit (Driver: </a:t>
+            </a:r>
+            <a:r>
+              <a:rPr lang="en-US" sz="2000" dirty="0" err="1"/>
+              <a:t>dfl-pci</a:t>
+            </a:r>
+            <a:r>
+              <a:rPr lang="en-US" sz="2000" dirty="0"/>
+              <a:t>)</a:t>
+            </a:r>
+          </a:p>
+          <a:p>
+            <a:pPr marL="0" indent="0">
+              <a:buNone/>
+            </a:pPr>
+            <a:endParaRPr lang="en-US" sz="2000" dirty="0"/>
+          </a:p>
+        </p:txBody>
+      </p:sp>
+    </p:spTree>
+    <p:extLst>
+      <p:ext uri="{BB962C8B-B14F-4D97-AF65-F5344CB8AC3E}">
+        <p14:creationId xmlns:p14="http://schemas.microsoft.com/office/powerpoint/2010/main" val="111103136"/>
+      </p:ext>
+    </p:extLst>
+  </p:cSld>
+  <p:clrMapOvr>
+    <a:masterClrMapping/>
+  </p:clrMapOvr>
+</p:sld>
+</file>
+
+<file path=ppt/slides/slide14.xml><?xml version="1.0" encoding="utf-8"?>
+<p:sld xmlns:a="http://schemas.openxmlformats.org/drawingml/2006/main" xmlns:r="http://schemas.openxmlformats.org/officeDocument/2006/relationships" xmlns:p="http://schemas.openxmlformats.org/presentationml/2006/main">
+  <p:cSld>
+    <p:spTree>
+      <p:nvGrpSpPr>
+        <p:cNvPr id="1" name="">
+          <a:extLst>
+            <a:ext uri="{FF2B5EF4-FFF2-40B4-BE49-F238E27FC236}">
+              <a16:creationId xmlns:a16="http://schemas.microsoft.com/office/drawing/2014/main" id="{A19CDFD2-2A4A-1002-D784-2F4276FDC192}"/>
+            </a:ext>
+          </a:extLst>
+        </p:cNvPr>
+        <p:cNvGrpSpPr/>
+        <p:nvPr/>
+      </p:nvGrpSpPr>
+      <p:grpSpPr>
+        <a:xfrm>
+          <a:off x="0" y="0"/>
+          <a:ext cx="0" cy="0"/>
+          <a:chOff x="0" y="0"/>
+          <a:chExt cx="0" cy="0"/>
+        </a:xfrm>
+      </p:grpSpPr>
+      <p:sp>
+        <p:nvSpPr>
+          <p:cNvPr id="3" name="Title 2">
+            <a:extLst>
+              <a:ext uri="{FF2B5EF4-FFF2-40B4-BE49-F238E27FC236}">
+                <a16:creationId xmlns:a16="http://schemas.microsoft.com/office/drawing/2014/main" id="{A4AF4AAF-BD1A-AA80-4D1F-0637535E704B}"/>
+              </a:ext>
+            </a:extLst>
+          </p:cNvPr>
+          <p:cNvSpPr>
+            <a:spLocks noGrp="1"/>
+          </p:cNvSpPr>
+          <p:nvPr>
+            <p:ph type="title" idx="4294967295"/>
+          </p:nvPr>
+        </p:nvSpPr>
+        <p:spPr>
+          <a:xfrm>
+            <a:off x="1220788" y="234950"/>
+            <a:ext cx="10971212" cy="1200150"/>
+          </a:xfrm>
+        </p:spPr>
+        <p:txBody>
+          <a:bodyPr/>
+          <a:lstStyle/>
+          <a:p>
+            <a:r>
+              <a:rPr lang="en-US" dirty="0"/>
+              <a:t>In-System Setup (3)</a:t>
+            </a:r>
+          </a:p>
+        </p:txBody>
+      </p:sp>
+      <p:sp>
+        <p:nvSpPr>
+          <p:cNvPr id="4" name="Text Placeholder 3">
+            <a:extLst>
+              <a:ext uri="{FF2B5EF4-FFF2-40B4-BE49-F238E27FC236}">
+                <a16:creationId xmlns:a16="http://schemas.microsoft.com/office/drawing/2014/main" id="{DB178826-1516-FADF-6063-5A2E0894CC65}"/>
+              </a:ext>
+            </a:extLst>
+          </p:cNvPr>
+          <p:cNvSpPr>
+            <a:spLocks noGrp="1"/>
+          </p:cNvSpPr>
+          <p:nvPr>
+            <p:ph type="body" idx="4294967295"/>
+          </p:nvPr>
+        </p:nvSpPr>
+        <p:spPr>
+          <a:xfrm>
+            <a:off x="0" y="1237673"/>
+            <a:ext cx="10625138" cy="5180544"/>
+          </a:xfrm>
+        </p:spPr>
+        <p:txBody>
+          <a:bodyPr>
+            <a:normAutofit fontScale="47500" lnSpcReduction="20000"/>
+          </a:bodyPr>
+          <a:lstStyle/>
+          <a:p>
+            <a:pPr marL="0" indent="0">
+              <a:buNone/>
+            </a:pPr>
+            <a:endParaRPr lang="en-US" sz="2000" dirty="0"/>
+          </a:p>
+          <a:p>
+            <a:pPr marL="0" indent="0">
+              <a:buNone/>
+            </a:pPr>
+            <a:r>
+              <a:rPr lang="en-US" sz="2000" dirty="0"/>
+              <a:t>[sse_team@spr02 /home/</a:t>
+            </a:r>
+            <a:r>
+              <a:rPr lang="en-US" sz="2000" dirty="0" err="1"/>
+              <a:t>sse_team</a:t>
+            </a:r>
+            <a:r>
+              <a:rPr lang="en-US" sz="2000" dirty="0"/>
+              <a:t>/</a:t>
+            </a:r>
+            <a:r>
+              <a:rPr lang="en-US" sz="2000" dirty="0" err="1"/>
+              <a:t>dgroen</a:t>
+            </a:r>
+            <a:r>
+              <a:rPr lang="en-US" sz="2000" dirty="0"/>
+              <a:t>]$ </a:t>
+            </a:r>
+            <a:r>
+              <a:rPr lang="en-US" sz="2000" dirty="0" err="1"/>
+              <a:t>sudo</a:t>
+            </a:r>
+            <a:r>
+              <a:rPr lang="en-US" sz="2000" dirty="0"/>
+              <a:t> opae.io </a:t>
+            </a:r>
+            <a:r>
+              <a:rPr lang="en-US" sz="2000" dirty="0" err="1"/>
+              <a:t>init</a:t>
+            </a:r>
+            <a:r>
+              <a:rPr lang="en-US" sz="2000" dirty="0"/>
+              <a:t> -d 0000:2a:00.3 </a:t>
+            </a:r>
+            <a:r>
+              <a:rPr lang="en-US" sz="2000" dirty="0" err="1"/>
+              <a:t>sse_team:sse_team</a:t>
+            </a:r>
+            <a:endParaRPr lang="en-US" sz="2000" dirty="0"/>
+          </a:p>
+          <a:p>
+            <a:pPr marL="0" indent="0">
+              <a:buNone/>
+            </a:pPr>
+            <a:r>
+              <a:rPr lang="en-US" sz="2000" dirty="0"/>
+              <a:t>Unbinding (0x8086,0xbccf) at 0000:2a:00.3 from </a:t>
+            </a:r>
+            <a:r>
+              <a:rPr lang="en-US" sz="2000" dirty="0" err="1"/>
+              <a:t>dfl-pci</a:t>
+            </a:r>
+            <a:endParaRPr lang="en-US" sz="2000" dirty="0"/>
+          </a:p>
+          <a:p>
+            <a:pPr marL="0" indent="0">
+              <a:buNone/>
+            </a:pPr>
+            <a:r>
+              <a:rPr lang="en-US" sz="2000" dirty="0"/>
+              <a:t>Binding (0x8086,0xbccf) at 0000:2a:00.3 to </a:t>
+            </a:r>
+            <a:r>
+              <a:rPr lang="en-US" sz="2000" dirty="0" err="1"/>
+              <a:t>vfio-pci</a:t>
+            </a:r>
+            <a:endParaRPr lang="en-US" sz="2000" dirty="0"/>
+          </a:p>
+          <a:p>
+            <a:pPr marL="0" indent="0">
+              <a:buNone/>
+            </a:pPr>
+            <a:r>
+              <a:rPr lang="en-US" sz="2000" dirty="0" err="1"/>
+              <a:t>iommu</a:t>
+            </a:r>
+            <a:r>
+              <a:rPr lang="en-US" sz="2000" dirty="0"/>
+              <a:t> group for (0x8086,0xbccf) at 0000:2a:00.3 is 228</a:t>
+            </a:r>
+          </a:p>
+          <a:p>
+            <a:pPr marL="0" indent="0">
+              <a:buNone/>
+            </a:pPr>
+            <a:r>
+              <a:rPr lang="en-US" sz="2000" dirty="0"/>
+              <a:t>Assigning /dev/</a:t>
+            </a:r>
+            <a:r>
+              <a:rPr lang="en-US" sz="2000" dirty="0" err="1"/>
+              <a:t>vfio</a:t>
+            </a:r>
+            <a:r>
+              <a:rPr lang="en-US" sz="2000" dirty="0"/>
+              <a:t>/228 to </a:t>
+            </a:r>
+            <a:r>
+              <a:rPr lang="en-US" sz="2000" dirty="0" err="1"/>
+              <a:t>sse_team:sse_team</a:t>
+            </a:r>
+            <a:endParaRPr lang="en-US" sz="2000" dirty="0"/>
+          </a:p>
+          <a:p>
+            <a:pPr marL="0" indent="0">
+              <a:buNone/>
+            </a:pPr>
+            <a:r>
+              <a:rPr lang="en-US" sz="2000" dirty="0"/>
+              <a:t>Changing permissions for /dev/</a:t>
+            </a:r>
+            <a:r>
+              <a:rPr lang="en-US" sz="2000" dirty="0" err="1"/>
+              <a:t>vfio</a:t>
+            </a:r>
+            <a:r>
+              <a:rPr lang="en-US" sz="2000" dirty="0"/>
+              <a:t>/228 to </a:t>
+            </a:r>
+            <a:r>
+              <a:rPr lang="en-US" sz="2000" dirty="0" err="1"/>
+              <a:t>rw</a:t>
+            </a:r>
+            <a:r>
+              <a:rPr lang="en-US" sz="2000" dirty="0"/>
+              <a:t>-</a:t>
+            </a:r>
+            <a:r>
+              <a:rPr lang="en-US" sz="2000" dirty="0" err="1"/>
+              <a:t>rw</a:t>
+            </a:r>
+            <a:r>
+              <a:rPr lang="en-US" sz="2000" dirty="0"/>
+              <a:t>----</a:t>
+            </a:r>
+          </a:p>
+          <a:p>
+            <a:pPr marL="0" indent="0">
+              <a:buNone/>
+            </a:pPr>
+            <a:r>
+              <a:rPr lang="en-US" sz="2000" dirty="0"/>
+              <a:t>[sse_team@spr02 /home/</a:t>
+            </a:r>
+            <a:r>
+              <a:rPr lang="en-US" sz="2000" dirty="0" err="1"/>
+              <a:t>sse_team</a:t>
+            </a:r>
+            <a:r>
+              <a:rPr lang="en-US" sz="2000" dirty="0"/>
+              <a:t>/</a:t>
+            </a:r>
+            <a:r>
+              <a:rPr lang="en-US" sz="2000" dirty="0" err="1"/>
+              <a:t>dgroen</a:t>
+            </a:r>
+            <a:r>
+              <a:rPr lang="en-US" sz="2000" dirty="0"/>
+              <a:t>]$ </a:t>
+            </a:r>
+            <a:r>
+              <a:rPr lang="en-US" sz="2000" dirty="0" err="1"/>
+              <a:t>sudo</a:t>
+            </a:r>
+            <a:r>
+              <a:rPr lang="en-US" sz="2000" dirty="0"/>
+              <a:t> opae.io </a:t>
+            </a:r>
+            <a:r>
+              <a:rPr lang="en-US" sz="2000" dirty="0" err="1"/>
+              <a:t>init</a:t>
+            </a:r>
+            <a:r>
+              <a:rPr lang="en-US" sz="2000" dirty="0"/>
+              <a:t> -d 0000:2b:00.3 </a:t>
+            </a:r>
+            <a:r>
+              <a:rPr lang="en-US" sz="2000" dirty="0" err="1"/>
+              <a:t>sse_team:sse_team</a:t>
+            </a:r>
+            <a:endParaRPr lang="en-US" sz="2000" dirty="0"/>
+          </a:p>
+          <a:p>
+            <a:pPr marL="0" indent="0">
+              <a:buNone/>
+            </a:pPr>
+            <a:r>
+              <a:rPr lang="en-US" sz="2000" dirty="0"/>
+              <a:t>Unbinding (0x8086,0xbccf) at 0000:2b:00.3 from </a:t>
+            </a:r>
+            <a:r>
+              <a:rPr lang="en-US" sz="2000" dirty="0" err="1"/>
+              <a:t>dfl-pci</a:t>
+            </a:r>
+            <a:endParaRPr lang="en-US" sz="2000" dirty="0"/>
+          </a:p>
+          <a:p>
+            <a:pPr marL="0" indent="0">
+              <a:buNone/>
+            </a:pPr>
+            <a:r>
+              <a:rPr lang="en-US" sz="2000" dirty="0"/>
+              <a:t>Binding (0x8086,0xbccf) at 0000:2b:00.3 to </a:t>
+            </a:r>
+            <a:r>
+              <a:rPr lang="en-US" sz="2000" dirty="0" err="1"/>
+              <a:t>vfio-pci</a:t>
+            </a:r>
+            <a:endParaRPr lang="en-US" sz="2000" dirty="0"/>
+          </a:p>
+          <a:p>
+            <a:pPr marL="0" indent="0">
+              <a:buNone/>
+            </a:pPr>
+            <a:r>
+              <a:rPr lang="en-US" sz="2000" dirty="0" err="1"/>
+              <a:t>iommu</a:t>
+            </a:r>
+            <a:r>
+              <a:rPr lang="en-US" sz="2000" dirty="0"/>
+              <a:t> group for (0x8086,0xbccf) at 0000:2b:00.3 is 229</a:t>
+            </a:r>
+          </a:p>
+          <a:p>
+            <a:pPr marL="0" indent="0">
+              <a:buNone/>
+            </a:pPr>
+            <a:r>
+              <a:rPr lang="en-US" sz="2000" dirty="0"/>
+              <a:t>Assigning /dev/</a:t>
+            </a:r>
+            <a:r>
+              <a:rPr lang="en-US" sz="2000" dirty="0" err="1"/>
+              <a:t>vfio</a:t>
+            </a:r>
+            <a:r>
+              <a:rPr lang="en-US" sz="2000" dirty="0"/>
+              <a:t>/229 to </a:t>
+            </a:r>
+            <a:r>
+              <a:rPr lang="en-US" sz="2000" dirty="0" err="1"/>
+              <a:t>sse_team:sse_team</a:t>
+            </a:r>
+            <a:endParaRPr lang="en-US" sz="2000" dirty="0"/>
+          </a:p>
+          <a:p>
+            <a:pPr marL="0" indent="0">
+              <a:buNone/>
+            </a:pPr>
+            <a:r>
+              <a:rPr lang="en-US" sz="2000" dirty="0"/>
+              <a:t>Changing permissions for /dev/</a:t>
+            </a:r>
+            <a:r>
+              <a:rPr lang="en-US" sz="2000" dirty="0" err="1"/>
+              <a:t>vfio</a:t>
+            </a:r>
+            <a:r>
+              <a:rPr lang="en-US" sz="2000" dirty="0"/>
+              <a:t>/229 to </a:t>
+            </a:r>
+            <a:r>
+              <a:rPr lang="en-US" sz="2000" dirty="0" err="1"/>
+              <a:t>rw</a:t>
+            </a:r>
+            <a:r>
+              <a:rPr lang="en-US" sz="2000" dirty="0"/>
+              <a:t>-</a:t>
+            </a:r>
+            <a:r>
+              <a:rPr lang="en-US" sz="2000" dirty="0" err="1"/>
+              <a:t>rw</a:t>
+            </a:r>
+            <a:r>
+              <a:rPr lang="en-US" sz="2000" dirty="0"/>
+              <a:t>----</a:t>
+            </a:r>
+          </a:p>
+          <a:p>
+            <a:pPr marL="0" indent="0">
+              <a:buNone/>
+            </a:pPr>
+            <a:r>
+              <a:rPr lang="en-US" sz="2000" dirty="0"/>
+              <a:t>[sse_team@spr02 /home/</a:t>
+            </a:r>
+            <a:r>
+              <a:rPr lang="en-US" sz="2000" dirty="0" err="1"/>
+              <a:t>sse_team</a:t>
+            </a:r>
+            <a:r>
+              <a:rPr lang="en-US" sz="2000" dirty="0"/>
+              <a:t>/</a:t>
+            </a:r>
+            <a:r>
+              <a:rPr lang="en-US" sz="2000" dirty="0" err="1"/>
+              <a:t>dgroen</a:t>
+            </a:r>
+            <a:r>
+              <a:rPr lang="en-US" sz="2000" dirty="0"/>
+              <a:t>]$  </a:t>
+            </a:r>
+            <a:r>
+              <a:rPr lang="en-US" sz="2000" dirty="0" err="1"/>
+              <a:t>sudo</a:t>
+            </a:r>
+            <a:r>
+              <a:rPr lang="en-US" sz="2000" dirty="0"/>
+              <a:t> opae.io ls</a:t>
+            </a:r>
+          </a:p>
+          <a:p>
+            <a:pPr marL="0" indent="0">
+              <a:buNone/>
+            </a:pPr>
+            <a:r>
+              <a:rPr lang="en-US" sz="2000" dirty="0"/>
+              <a:t>[0000:2b:00.3] (0x8086:0xbccf 0x8086:0x0001) Intel Acceleration JTAG PCI Development Kit (Driver: </a:t>
+            </a:r>
+            <a:r>
+              <a:rPr lang="en-US" sz="2000" dirty="0" err="1"/>
+              <a:t>vfio-pci</a:t>
+            </a:r>
+            <a:r>
+              <a:rPr lang="en-US" sz="2000" dirty="0"/>
+              <a:t>)</a:t>
+            </a:r>
+          </a:p>
+          <a:p>
+            <a:pPr marL="0" indent="0">
+              <a:buNone/>
+            </a:pPr>
+            <a:r>
+              <a:rPr lang="en-US" sz="2000" dirty="0"/>
+              <a:t>[0000:2b:00.1] (0x8086:0xbcce 0x8086:0x0001) Intel Acceleration JTAG PCI Development Kit (Driver: </a:t>
+            </a:r>
+            <a:r>
+              <a:rPr lang="en-US" sz="2000" dirty="0" err="1"/>
+              <a:t>dfl-pci</a:t>
+            </a:r>
+            <a:r>
+              <a:rPr lang="en-US" sz="2000" dirty="0"/>
+              <a:t>)</a:t>
+            </a:r>
+          </a:p>
+          <a:p>
+            <a:pPr marL="0" indent="0">
+              <a:buNone/>
+            </a:pPr>
+            <a:r>
+              <a:rPr lang="en-US" sz="2000" dirty="0"/>
+              <a:t>[0000:2a:00.3] (0x8086:0xbccf 0x8086:0x0001) Intel Acceleration JTAG PCI Development Kit (Driver: </a:t>
+            </a:r>
+            <a:r>
+              <a:rPr lang="en-US" sz="2000" dirty="0" err="1"/>
+              <a:t>vfio-pci</a:t>
+            </a:r>
+            <a:r>
+              <a:rPr lang="en-US" sz="2000" dirty="0"/>
+              <a:t>)</a:t>
+            </a:r>
+          </a:p>
+          <a:p>
+            <a:pPr marL="0" indent="0">
+              <a:buNone/>
+            </a:pPr>
+            <a:r>
+              <a:rPr lang="en-US" sz="2000" dirty="0"/>
+              <a:t>[0000:2a:00.1] (0x8086:0xbcce 0x8086:0x0001) Intel Acceleration JTAG PCI Development Kit (Driver: </a:t>
+            </a:r>
+            <a:r>
+              <a:rPr lang="en-US" sz="2000" dirty="0" err="1"/>
+              <a:t>dfl-pci</a:t>
+            </a:r>
+            <a:r>
+              <a:rPr lang="en-US" sz="2000" dirty="0"/>
+              <a:t>)</a:t>
+            </a:r>
+          </a:p>
+          <a:p>
+            <a:pPr marL="0" indent="0">
+              <a:buNone/>
+            </a:pPr>
+            <a:r>
+              <a:rPr lang="en-US" sz="2000" dirty="0"/>
+              <a:t>[0000:2b:00.2] (0x8086:0xbcce 0x8086:0x0001) Intel Acceleration JTAG PCI Development Kit (Driver: </a:t>
+            </a:r>
+            <a:r>
+              <a:rPr lang="en-US" sz="2000" dirty="0" err="1"/>
+              <a:t>dfl-pci</a:t>
+            </a:r>
+            <a:r>
+              <a:rPr lang="en-US" sz="2000" dirty="0"/>
+              <a:t>)</a:t>
+            </a:r>
+          </a:p>
+          <a:p>
+            <a:pPr marL="0" indent="0">
+              <a:buNone/>
+            </a:pPr>
+            <a:r>
+              <a:rPr lang="en-US" sz="2000" dirty="0"/>
+              <a:t>[0000:2b:00.0] (0x8086:0xbcce 0x8086:0x0001) Intel Acceleration JTAG PCI Development Kit (Driver: </a:t>
+            </a:r>
+            <a:r>
+              <a:rPr lang="en-US" sz="2000" dirty="0" err="1"/>
+              <a:t>dfl-pci</a:t>
+            </a:r>
+            <a:r>
+              <a:rPr lang="en-US" sz="2000" dirty="0"/>
+              <a:t>)</a:t>
+            </a:r>
+          </a:p>
+          <a:p>
+            <a:pPr marL="0" indent="0">
+              <a:buNone/>
+            </a:pPr>
+            <a:r>
+              <a:rPr lang="en-US" sz="2000" dirty="0"/>
+              <a:t>[0000:2a:00.2] (0x8086:0xbcce 0x8086:0x0001) Intel Acceleration JTAG PCI Development Kit (Driver: </a:t>
+            </a:r>
+            <a:r>
+              <a:rPr lang="en-US" sz="2000" dirty="0" err="1"/>
+              <a:t>dfl-pci</a:t>
+            </a:r>
+            <a:r>
+              <a:rPr lang="en-US" sz="2000" dirty="0"/>
+              <a:t>)</a:t>
+            </a:r>
+          </a:p>
+          <a:p>
+            <a:pPr marL="0" indent="0">
+              <a:buNone/>
+            </a:pPr>
+            <a:r>
+              <a:rPr lang="en-US" sz="2000" dirty="0"/>
+              <a:t>[0000:2a:00.0] (0x8086:0xbcce 0x8086:0x0001) Intel Acceleration JTAG PCI Development Kit (Driver: </a:t>
+            </a:r>
+            <a:r>
+              <a:rPr lang="en-US" sz="2000" dirty="0" err="1"/>
+              <a:t>dfl-pci</a:t>
+            </a:r>
+            <a:r>
+              <a:rPr lang="en-US" sz="2000" dirty="0"/>
+              <a:t>)</a:t>
+            </a:r>
+          </a:p>
+          <a:p>
+            <a:pPr marL="0" indent="0">
+              <a:buNone/>
+            </a:pPr>
+            <a:endParaRPr lang="en-US" sz="2000" dirty="0"/>
+          </a:p>
+        </p:txBody>
+      </p:sp>
+    </p:spTree>
+    <p:extLst>
+      <p:ext uri="{BB962C8B-B14F-4D97-AF65-F5344CB8AC3E}">
+        <p14:creationId xmlns:p14="http://schemas.microsoft.com/office/powerpoint/2010/main" val="2124930273"/>
+      </p:ext>
+    </p:extLst>
+  </p:cSld>
+  <p:clrMapOvr>
+    <a:masterClrMapping/>
+  </p:clrMapOvr>
+</p:sld>
+</file>
+
+<file path=ppt/slides/slide15.xml><?xml version="1.0" encoding="utf-8"?>
+<p:sld xmlns:a="http://schemas.openxmlformats.org/drawingml/2006/main" xmlns:r="http://schemas.openxmlformats.org/officeDocument/2006/relationships" xmlns:p="http://schemas.openxmlformats.org/presentationml/2006/main">
+  <p:cSld>
+    <p:spTree>
+      <p:nvGrpSpPr>
+        <p:cNvPr id="1" name="">
+          <a:extLst>
+            <a:ext uri="{FF2B5EF4-FFF2-40B4-BE49-F238E27FC236}">
+              <a16:creationId xmlns:a16="http://schemas.microsoft.com/office/drawing/2014/main" id="{70B471BF-9ECE-F799-2C44-B1447829E780}"/>
+            </a:ext>
+          </a:extLst>
+        </p:cNvPr>
+        <p:cNvGrpSpPr/>
+        <p:nvPr/>
+      </p:nvGrpSpPr>
+      <p:grpSpPr>
+        <a:xfrm>
+          <a:off x="0" y="0"/>
+          <a:ext cx="0" cy="0"/>
+          <a:chOff x="0" y="0"/>
+          <a:chExt cx="0" cy="0"/>
+        </a:xfrm>
+      </p:grpSpPr>
+      <p:sp>
+        <p:nvSpPr>
+          <p:cNvPr id="3" name="Title 2">
+            <a:extLst>
+              <a:ext uri="{FF2B5EF4-FFF2-40B4-BE49-F238E27FC236}">
+                <a16:creationId xmlns:a16="http://schemas.microsoft.com/office/drawing/2014/main" id="{DCBA070C-D419-ECB1-B305-D2EFD6DEC660}"/>
+              </a:ext>
+            </a:extLst>
+          </p:cNvPr>
+          <p:cNvSpPr>
+            <a:spLocks noGrp="1"/>
+          </p:cNvSpPr>
+          <p:nvPr>
+            <p:ph type="title" idx="4294967295"/>
+          </p:nvPr>
+        </p:nvSpPr>
+        <p:spPr>
+          <a:xfrm>
+            <a:off x="1220788" y="234950"/>
+            <a:ext cx="10971212" cy="1200150"/>
+          </a:xfrm>
+        </p:spPr>
+        <p:txBody>
+          <a:bodyPr/>
+          <a:lstStyle/>
+          <a:p>
+            <a:r>
+              <a:rPr lang="en-US" dirty="0"/>
+              <a:t>In-System Setup (4)</a:t>
+            </a:r>
+          </a:p>
+        </p:txBody>
+      </p:sp>
+      <p:sp>
+        <p:nvSpPr>
+          <p:cNvPr id="4" name="Text Placeholder 3">
+            <a:extLst>
+              <a:ext uri="{FF2B5EF4-FFF2-40B4-BE49-F238E27FC236}">
+                <a16:creationId xmlns:a16="http://schemas.microsoft.com/office/drawing/2014/main" id="{B9D53F2A-53FB-7317-6EA4-DFB39881B44E}"/>
+              </a:ext>
+            </a:extLst>
+          </p:cNvPr>
+          <p:cNvSpPr>
+            <a:spLocks noGrp="1"/>
+          </p:cNvSpPr>
+          <p:nvPr>
+            <p:ph type="body" idx="4294967295"/>
+          </p:nvPr>
+        </p:nvSpPr>
+        <p:spPr>
+          <a:xfrm>
+            <a:off x="0" y="1509713"/>
+            <a:ext cx="10625138" cy="4908504"/>
+          </a:xfrm>
+        </p:spPr>
+        <p:txBody>
+          <a:bodyPr>
+            <a:normAutofit/>
+          </a:bodyPr>
+          <a:lstStyle/>
+          <a:p>
+            <a:pPr marL="0" indent="0">
+              <a:buNone/>
+            </a:pPr>
+            <a:endParaRPr lang="en-US" sz="2000" dirty="0"/>
+          </a:p>
+          <a:p>
+            <a:pPr marL="0" indent="0">
+              <a:buNone/>
+            </a:pPr>
+            <a:r>
+              <a:rPr lang="en-US" sz="2000" dirty="0"/>
+              <a:t>$ </a:t>
+            </a:r>
+            <a:r>
+              <a:rPr lang="en-US" sz="2000" dirty="0" err="1"/>
+              <a:t>lspci</a:t>
+            </a:r>
+            <a:r>
+              <a:rPr lang="en-US" sz="2000" dirty="0"/>
+              <a:t> | grep accel</a:t>
+            </a:r>
+          </a:p>
+          <a:p>
+            <a:pPr marL="0" indent="0">
+              <a:buNone/>
+            </a:pPr>
+            <a:r>
+              <a:rPr lang="en-US" sz="2000" dirty="0"/>
+              <a:t>2a:00.0 Processing accelerators: Intel Corporation Device </a:t>
+            </a:r>
+            <a:r>
+              <a:rPr lang="en-US" sz="2000" dirty="0" err="1"/>
+              <a:t>bcce</a:t>
+            </a:r>
+            <a:r>
+              <a:rPr lang="en-US" sz="2000" dirty="0"/>
+              <a:t> (rev 01)</a:t>
+            </a:r>
+          </a:p>
+          <a:p>
+            <a:pPr marL="0" indent="0">
+              <a:buNone/>
+            </a:pPr>
+            <a:r>
+              <a:rPr lang="en-US" sz="2000" dirty="0"/>
+              <a:t>2a:00.1 Processing accelerators: Intel Corporation Device </a:t>
+            </a:r>
+            <a:r>
+              <a:rPr lang="en-US" sz="2000" dirty="0" err="1"/>
+              <a:t>bcce</a:t>
+            </a:r>
+            <a:r>
+              <a:rPr lang="en-US" sz="2000" dirty="0"/>
+              <a:t> (rev 01)</a:t>
+            </a:r>
+          </a:p>
+          <a:p>
+            <a:pPr marL="0" indent="0">
+              <a:buNone/>
+            </a:pPr>
+            <a:r>
+              <a:rPr lang="en-US" sz="2000" dirty="0"/>
+              <a:t>2a:00.2 Processing accelerators: Intel Corporation Device </a:t>
+            </a:r>
+            <a:r>
+              <a:rPr lang="en-US" sz="2000" dirty="0" err="1"/>
+              <a:t>bcce</a:t>
+            </a:r>
+            <a:r>
+              <a:rPr lang="en-US" sz="2000" dirty="0"/>
+              <a:t> (rev 01)</a:t>
+            </a:r>
+          </a:p>
+          <a:p>
+            <a:pPr marL="0" indent="0">
+              <a:buNone/>
+            </a:pPr>
+            <a:r>
+              <a:rPr lang="en-US" sz="2000" dirty="0"/>
+              <a:t>2a:00.3 Processing accelerators: Intel Corporation Device </a:t>
+            </a:r>
+            <a:r>
+              <a:rPr lang="en-US" sz="2000" dirty="0" err="1"/>
+              <a:t>bccf</a:t>
+            </a:r>
+            <a:endParaRPr lang="en-US" sz="2000" dirty="0"/>
+          </a:p>
+          <a:p>
+            <a:pPr marL="0" indent="0">
+              <a:buNone/>
+            </a:pPr>
+            <a:r>
+              <a:rPr lang="en-US" sz="2000" dirty="0"/>
+              <a:t>2b:00.0 Processing accelerators: Intel Corporation Device </a:t>
+            </a:r>
+            <a:r>
+              <a:rPr lang="en-US" sz="2000" dirty="0" err="1"/>
+              <a:t>bcce</a:t>
+            </a:r>
+            <a:r>
+              <a:rPr lang="en-US" sz="2000" dirty="0"/>
+              <a:t> (rev 01)</a:t>
+            </a:r>
+          </a:p>
+          <a:p>
+            <a:pPr marL="0" indent="0">
+              <a:buNone/>
+            </a:pPr>
+            <a:r>
+              <a:rPr lang="en-US" sz="2000" dirty="0"/>
+              <a:t>2b:00.1 Processing accelerators: Intel Corporation Device </a:t>
+            </a:r>
+            <a:r>
+              <a:rPr lang="en-US" sz="2000" dirty="0" err="1"/>
+              <a:t>bcce</a:t>
+            </a:r>
+            <a:r>
+              <a:rPr lang="en-US" sz="2000" dirty="0"/>
+              <a:t> (rev 01)</a:t>
+            </a:r>
+          </a:p>
+          <a:p>
+            <a:pPr marL="0" indent="0">
+              <a:buNone/>
+            </a:pPr>
+            <a:r>
+              <a:rPr lang="en-US" sz="2000" dirty="0"/>
+              <a:t>2b:00.2 Processing accelerators: Intel Corporation Device </a:t>
+            </a:r>
+            <a:r>
+              <a:rPr lang="en-US" sz="2000" dirty="0" err="1"/>
+              <a:t>bcce</a:t>
+            </a:r>
+            <a:r>
+              <a:rPr lang="en-US" sz="2000" dirty="0"/>
+              <a:t> (rev 01)</a:t>
+            </a:r>
+          </a:p>
+          <a:p>
+            <a:pPr marL="0" indent="0">
+              <a:buNone/>
+            </a:pPr>
+            <a:r>
+              <a:rPr lang="en-US" sz="2000" dirty="0"/>
+              <a:t>2b:00.3 Processing accelerators: Intel Corporation Device </a:t>
+            </a:r>
+            <a:r>
+              <a:rPr lang="en-US" sz="2000" dirty="0" err="1"/>
+              <a:t>bccf</a:t>
+            </a:r>
+            <a:endParaRPr lang="en-US" sz="2000" dirty="0"/>
+          </a:p>
+          <a:p>
+            <a:pPr marL="0" indent="0">
+              <a:buNone/>
+            </a:pPr>
+            <a:endParaRPr lang="en-US" sz="2000" dirty="0"/>
+          </a:p>
+        </p:txBody>
+      </p:sp>
+    </p:spTree>
+    <p:extLst>
+      <p:ext uri="{BB962C8B-B14F-4D97-AF65-F5344CB8AC3E}">
+        <p14:creationId xmlns:p14="http://schemas.microsoft.com/office/powerpoint/2010/main" val="799516042"/>
+      </p:ext>
+    </p:extLst>
+  </p:cSld>
+  <p:clrMapOvr>
+    <a:masterClrMapping/>
+  </p:clrMapOvr>
+</p:sld>
+</file>
+
+<file path=ppt/slides/slide16.xml><?xml version="1.0" encoding="utf-8"?>
+<p:sld xmlns:a="http://schemas.openxmlformats.org/drawingml/2006/main" xmlns:r="http://schemas.openxmlformats.org/officeDocument/2006/relationships" xmlns:p="http://schemas.openxmlformats.org/presentationml/2006/main">
+  <p:cSld>
+    <p:spTree>
+      <p:nvGrpSpPr>
+        <p:cNvPr id="1" name="">
+          <a:extLst>
+            <a:ext uri="{FF2B5EF4-FFF2-40B4-BE49-F238E27FC236}">
+              <a16:creationId xmlns:a16="http://schemas.microsoft.com/office/drawing/2014/main" id="{DBFA31EC-91F5-2C4A-68DF-9DF2CAD5357F}"/>
+            </a:ext>
+          </a:extLst>
+        </p:cNvPr>
+        <p:cNvGrpSpPr/>
+        <p:nvPr/>
+      </p:nvGrpSpPr>
+      <p:grpSpPr>
+        <a:xfrm>
+          <a:off x="0" y="0"/>
+          <a:ext cx="0" cy="0"/>
+          <a:chOff x="0" y="0"/>
+          <a:chExt cx="0" cy="0"/>
+        </a:xfrm>
+      </p:grpSpPr>
+      <p:pic>
+        <p:nvPicPr>
+          <p:cNvPr id="5" name="Picture 4" descr="A diagram of a flowchart&#10;&#10;Description automatically generated">
+            <a:extLst>
+              <a:ext uri="{FF2B5EF4-FFF2-40B4-BE49-F238E27FC236}">
+                <a16:creationId xmlns:a16="http://schemas.microsoft.com/office/drawing/2014/main" id="{0BE1D7D3-7C5A-6709-4DFF-EB93E63E3D60}"/>
+              </a:ext>
+            </a:extLst>
+          </p:cNvPr>
+          <p:cNvPicPr>
+            <a:picLocks noChangeAspect="1"/>
+          </p:cNvPicPr>
+          <p:nvPr/>
+        </p:nvPicPr>
+        <p:blipFill>
+          <a:blip r:embed="rId2">
+            <a:extLst>
+              <a:ext uri="{28A0092B-C50C-407E-A947-70E740481C1C}">
+                <a14:useLocalDpi xmlns:a14="http://schemas.microsoft.com/office/drawing/2010/main" val="0"/>
+              </a:ext>
+            </a:extLst>
+          </a:blip>
+          <a:stretch>
+            <a:fillRect/>
+          </a:stretch>
+        </p:blipFill>
+        <p:spPr>
+          <a:xfrm>
+            <a:off x="1589" y="295207"/>
+            <a:ext cx="12188825" cy="6105594"/>
+          </a:xfrm>
+          <a:prstGeom prst="rect">
+            <a:avLst/>
+          </a:prstGeom>
+        </p:spPr>
+      </p:pic>
+    </p:spTree>
+    <p:extLst>
+      <p:ext uri="{BB962C8B-B14F-4D97-AF65-F5344CB8AC3E}">
+        <p14:creationId xmlns:p14="http://schemas.microsoft.com/office/powerpoint/2010/main" val="612669385"/>
+      </p:ext>
+    </p:extLst>
+  </p:cSld>
+  <p:clrMapOvr>
+    <a:masterClrMapping/>
+  </p:clrMapOvr>
+</p:sld>
+</file>
+
 <file path=ppt/slides/slide2.xml><?xml version="1.0" encoding="utf-8"?>
 <p:sld xmlns:a="http://schemas.openxmlformats.org/drawingml/2006/main" xmlns:r="http://schemas.openxmlformats.org/officeDocument/2006/relationships" xmlns:p="http://schemas.openxmlformats.org/presentationml/2006/main">
   <p:cSld>
@@ -4273,12 +6361,14 @@
         </p:nvSpPr>
         <p:spPr>
           <a:xfrm>
-            <a:off x="0" y="2063750"/>
-            <a:ext cx="10609263" cy="3195638"/>
+            <a:off x="0" y="1589903"/>
+            <a:ext cx="10609263" cy="4497859"/>
           </a:xfrm>
         </p:spPr>
         <p:txBody>
-          <a:bodyPr/>
+          <a:bodyPr>
+            <a:normAutofit/>
+          </a:bodyPr>
           <a:lstStyle/>
           <a:p>
             <a:r>
@@ -4314,6 +6404,18 @@
             <a:r>
               <a:rPr lang="en-US" sz="2400" dirty="0"/>
               <a:t>New `defines to enable changes to the kernel-system’s port-list</a:t>
+            </a:r>
+          </a:p>
+          <a:p>
+            <a:r>
+              <a:rPr lang="en-US" sz="2400" dirty="0"/>
+              <a:t>Different handling of parent and child AXI-ST interfaces</a:t>
+            </a:r>
+          </a:p>
+          <a:p>
+            <a:r>
+              <a:rPr lang="en-US" sz="2400" dirty="0"/>
+              <a:t>DMA controller splits each transfer across the 2 links</a:t>
             </a:r>
           </a:p>
           <a:p>
@@ -4368,6 +6470,324 @@
 </file>
 
 <file path=ppt/slides/slide5.xml><?xml version="1.0" encoding="utf-8"?>
+<p:sld xmlns:a="http://schemas.openxmlformats.org/drawingml/2006/main" xmlns:r="http://schemas.openxmlformats.org/officeDocument/2006/relationships" xmlns:p="http://schemas.openxmlformats.org/presentationml/2006/main">
+  <p:cSld>
+    <p:spTree>
+      <p:nvGrpSpPr>
+        <p:cNvPr id="1" name="">
+          <a:extLst>
+            <a:ext uri="{FF2B5EF4-FFF2-40B4-BE49-F238E27FC236}">
+              <a16:creationId xmlns:a16="http://schemas.microsoft.com/office/drawing/2014/main" id="{A2DF88FE-9845-CA7D-3358-B2E145EEBA94}"/>
+            </a:ext>
+          </a:extLst>
+        </p:cNvPr>
+        <p:cNvGrpSpPr/>
+        <p:nvPr/>
+      </p:nvGrpSpPr>
+      <p:grpSpPr>
+        <a:xfrm>
+          <a:off x="0" y="0"/>
+          <a:ext cx="0" cy="0"/>
+          <a:chOff x="0" y="0"/>
+          <a:chExt cx="0" cy="0"/>
+        </a:xfrm>
+      </p:grpSpPr>
+      <p:sp>
+        <p:nvSpPr>
+          <p:cNvPr id="3" name="Title 2">
+            <a:extLst>
+              <a:ext uri="{FF2B5EF4-FFF2-40B4-BE49-F238E27FC236}">
+                <a16:creationId xmlns:a16="http://schemas.microsoft.com/office/drawing/2014/main" id="{ED34024D-598E-79B7-6B37-059905D4DB8F}"/>
+              </a:ext>
+            </a:extLst>
+          </p:cNvPr>
+          <p:cNvSpPr>
+            <a:spLocks noGrp="1"/>
+          </p:cNvSpPr>
+          <p:nvPr>
+            <p:ph type="title" idx="4294967295"/>
+          </p:nvPr>
+        </p:nvSpPr>
+        <p:spPr>
+          <a:xfrm>
+            <a:off x="280086" y="234950"/>
+            <a:ext cx="11911914" cy="1200150"/>
+          </a:xfrm>
+        </p:spPr>
+        <p:txBody>
+          <a:bodyPr/>
+          <a:lstStyle/>
+          <a:p>
+            <a:r>
+              <a:rPr lang="en-US" dirty="0"/>
+              <a:t>Changes to AXI/AVMM Conversion </a:t>
+            </a:r>
+            <a:r>
+              <a:rPr lang="en-US"/>
+              <a:t>(PIM Modules)</a:t>
+            </a:r>
+            <a:endParaRPr lang="en-US" dirty="0"/>
+          </a:p>
+        </p:txBody>
+      </p:sp>
+      <p:sp>
+        <p:nvSpPr>
+          <p:cNvPr id="4" name="Text Placeholder 3">
+            <a:extLst>
+              <a:ext uri="{FF2B5EF4-FFF2-40B4-BE49-F238E27FC236}">
+                <a16:creationId xmlns:a16="http://schemas.microsoft.com/office/drawing/2014/main" id="{0AB38191-01E7-ADCA-1EE0-899B77DEBA47}"/>
+              </a:ext>
+            </a:extLst>
+          </p:cNvPr>
+          <p:cNvSpPr>
+            <a:spLocks noGrp="1"/>
+          </p:cNvSpPr>
+          <p:nvPr>
+            <p:ph type="body" idx="4294967295"/>
+          </p:nvPr>
+        </p:nvSpPr>
+        <p:spPr>
+          <a:xfrm>
+            <a:off x="0" y="1509713"/>
+            <a:ext cx="10625138" cy="4276725"/>
+          </a:xfrm>
+        </p:spPr>
+        <p:txBody>
+          <a:bodyPr>
+            <a:normAutofit fontScale="92500"/>
+          </a:bodyPr>
+          <a:lstStyle/>
+          <a:p>
+            <a:r>
+              <a:rPr lang="en-US" dirty="0"/>
+              <a:t>The Parent link remains the same – AXI-ST[0]</a:t>
+            </a:r>
+          </a:p>
+          <a:p>
+            <a:pPr lvl="1"/>
+            <a:r>
+              <a:rPr lang="en-US" dirty="0"/>
+              <a:t>Leverages the PIM’s </a:t>
+            </a:r>
+            <a:r>
+              <a:rPr lang="en-US" dirty="0" err="1"/>
+              <a:t>ofs_plat_host_chan_as_avalon_mem_rdwr_with_mmio</a:t>
+            </a:r>
+            <a:r>
+              <a:rPr lang="en-US" dirty="0"/>
+              <a:t> module to give us the host-mem AVMM_RDWR interface and a MMIO64 AVMM interface for the ASP</a:t>
+            </a:r>
+          </a:p>
+          <a:p>
+            <a:pPr lvl="1"/>
+            <a:r>
+              <a:rPr lang="en-US" dirty="0"/>
+              <a:t>This link’s AFU ID / DFL information changes to indicate there is a child link, including the child’s GUID</a:t>
+            </a:r>
+          </a:p>
+          <a:p>
+            <a:r>
+              <a:rPr lang="en-US" dirty="0"/>
+              <a:t>The Child AXI-ST link is AXI-ST[1]</a:t>
+            </a:r>
+          </a:p>
+          <a:p>
+            <a:pPr lvl="1"/>
+            <a:r>
+              <a:rPr lang="en-US" dirty="0"/>
+              <a:t>Uses the PIM’s </a:t>
+            </a:r>
+            <a:r>
+              <a:rPr lang="en-US" dirty="0" err="1"/>
+              <a:t>ofs_plat_host_chan_fim_multi_link_afu_dfh</a:t>
+            </a:r>
+            <a:r>
+              <a:rPr lang="en-US" dirty="0"/>
+              <a:t> with the child’s GUID</a:t>
+            </a:r>
+          </a:p>
+          <a:p>
+            <a:pPr lvl="1"/>
+            <a:r>
+              <a:rPr lang="en-US" dirty="0"/>
+              <a:t>The PIM’s AXI-ST / AVMM_RDWR conversion occurs using </a:t>
+            </a:r>
+            <a:r>
+              <a:rPr lang="en-US" dirty="0" err="1"/>
+              <a:t>ofs_plat_host_chan_as_avalon_mem_rdwr</a:t>
+            </a:r>
+            <a:r>
+              <a:rPr lang="en-US" dirty="0"/>
+              <a:t>, which is similar to the parent link except it doesn’t include the MMIO AVMM interface (the only MMIO transactions handled on the child link are the DFH transactions)</a:t>
+            </a:r>
+          </a:p>
+          <a:p>
+            <a:endParaRPr lang="en-US" sz="2400" dirty="0"/>
+          </a:p>
+        </p:txBody>
+      </p:sp>
+    </p:spTree>
+    <p:extLst>
+      <p:ext uri="{BB962C8B-B14F-4D97-AF65-F5344CB8AC3E}">
+        <p14:creationId xmlns:p14="http://schemas.microsoft.com/office/powerpoint/2010/main" val="2364973407"/>
+      </p:ext>
+    </p:extLst>
+  </p:cSld>
+  <p:clrMapOvr>
+    <a:masterClrMapping/>
+  </p:clrMapOvr>
+</p:sld>
+</file>
+
+<file path=ppt/slides/slide6.xml><?xml version="1.0" encoding="utf-8"?>
+<p:sld xmlns:a="http://schemas.openxmlformats.org/drawingml/2006/main" xmlns:r="http://schemas.openxmlformats.org/officeDocument/2006/relationships" xmlns:p="http://schemas.openxmlformats.org/presentationml/2006/main">
+  <p:cSld>
+    <p:spTree>
+      <p:nvGrpSpPr>
+        <p:cNvPr id="1" name="">
+          <a:extLst>
+            <a:ext uri="{FF2B5EF4-FFF2-40B4-BE49-F238E27FC236}">
+              <a16:creationId xmlns:a16="http://schemas.microsoft.com/office/drawing/2014/main" id="{BDA5B342-9FE5-CEA2-A631-A99D5B8CFDED}"/>
+            </a:ext>
+          </a:extLst>
+        </p:cNvPr>
+        <p:cNvGrpSpPr/>
+        <p:nvPr/>
+      </p:nvGrpSpPr>
+      <p:grpSpPr>
+        <a:xfrm>
+          <a:off x="0" y="0"/>
+          <a:ext cx="0" cy="0"/>
+          <a:chOff x="0" y="0"/>
+          <a:chExt cx="0" cy="0"/>
+        </a:xfrm>
+      </p:grpSpPr>
+      <p:sp>
+        <p:nvSpPr>
+          <p:cNvPr id="3" name="Title 2">
+            <a:extLst>
+              <a:ext uri="{FF2B5EF4-FFF2-40B4-BE49-F238E27FC236}">
+                <a16:creationId xmlns:a16="http://schemas.microsoft.com/office/drawing/2014/main" id="{7B049716-59C0-2FB1-72BE-923CF75EB2BC}"/>
+              </a:ext>
+            </a:extLst>
+          </p:cNvPr>
+          <p:cNvSpPr>
+            <a:spLocks noGrp="1"/>
+          </p:cNvSpPr>
+          <p:nvPr>
+            <p:ph type="title" idx="4294967295"/>
+          </p:nvPr>
+        </p:nvSpPr>
+        <p:spPr>
+          <a:xfrm>
+            <a:off x="1220788" y="234950"/>
+            <a:ext cx="10971212" cy="1200150"/>
+          </a:xfrm>
+        </p:spPr>
+        <p:txBody>
+          <a:bodyPr/>
+          <a:lstStyle/>
+          <a:p>
+            <a:r>
+              <a:rPr lang="en-US" dirty="0"/>
+              <a:t>Changes to VTP Connections</a:t>
+            </a:r>
+          </a:p>
+        </p:txBody>
+      </p:sp>
+      <p:sp>
+        <p:nvSpPr>
+          <p:cNvPr id="4" name="Text Placeholder 3">
+            <a:extLst>
+              <a:ext uri="{FF2B5EF4-FFF2-40B4-BE49-F238E27FC236}">
+                <a16:creationId xmlns:a16="http://schemas.microsoft.com/office/drawing/2014/main" id="{2D8E3E7E-EB71-312D-B9BE-AE329CB4153E}"/>
+              </a:ext>
+            </a:extLst>
+          </p:cNvPr>
+          <p:cNvSpPr>
+            <a:spLocks noGrp="1"/>
+          </p:cNvSpPr>
+          <p:nvPr>
+            <p:ph type="body" idx="4294967295"/>
+          </p:nvPr>
+        </p:nvSpPr>
+        <p:spPr>
+          <a:xfrm>
+            <a:off x="0" y="1509713"/>
+            <a:ext cx="10625138" cy="4276725"/>
+          </a:xfrm>
+        </p:spPr>
+        <p:txBody>
+          <a:bodyPr/>
+          <a:lstStyle/>
+          <a:p>
+            <a:r>
+              <a:rPr lang="en-US" sz="2400" dirty="0"/>
+              <a:t>No changes needed in mmd – the mmd doesn’t know there are multiple links</a:t>
+            </a:r>
+          </a:p>
+          <a:p>
+            <a:r>
+              <a:rPr lang="en-US" sz="2400" dirty="0"/>
+              <a:t>The host-memory space is common across both of the PCIe interfaces, which means we can use a single VTP-service block on the parent MMIO link</a:t>
+            </a:r>
+          </a:p>
+          <a:p>
+            <a:r>
+              <a:rPr lang="en-US" sz="2400" dirty="0"/>
+              <a:t>Add new VTP-translation modules for the new links</a:t>
+            </a:r>
+          </a:p>
+          <a:p>
+            <a:pPr lvl="1"/>
+            <a:r>
+              <a:rPr lang="en-US" dirty="0"/>
+              <a:t>Increase the number of </a:t>
+            </a:r>
+            <a:r>
+              <a:rPr lang="en-US" dirty="0" err="1"/>
+              <a:t>vtp_port</a:t>
+            </a:r>
+            <a:r>
+              <a:rPr lang="en-US" dirty="0"/>
+              <a:t> interfaces such that each DMA and USM VTP-translation module has 2 ports</a:t>
+            </a:r>
+          </a:p>
+          <a:p>
+            <a:r>
+              <a:rPr lang="en-US" sz="2400" dirty="0"/>
+              <a:t>Link 0 (the parent link) will carry the same traffic it used to carry</a:t>
+            </a:r>
+          </a:p>
+          <a:p>
+            <a:pPr lvl="1"/>
+            <a:r>
+              <a:rPr lang="en-US" dirty="0"/>
+              <a:t>Normal MMIO transactions, DMA[0] and USM[0] traffic, VTP services</a:t>
+            </a:r>
+          </a:p>
+          <a:p>
+            <a:r>
+              <a:rPr lang="en-US" sz="2400" dirty="0"/>
+              <a:t>Link 1 (the child link) will only carry DMA[1] and USM[1] traffic (and a very basic child-DFH response)</a:t>
+            </a:r>
+          </a:p>
+        </p:txBody>
+      </p:sp>
+    </p:spTree>
+    <p:extLst>
+      <p:ext uri="{BB962C8B-B14F-4D97-AF65-F5344CB8AC3E}">
+        <p14:creationId xmlns:p14="http://schemas.microsoft.com/office/powerpoint/2010/main" val="3906631731"/>
+      </p:ext>
+    </p:extLst>
+  </p:cSld>
+  <p:clrMapOvr>
+    <a:masterClrMapping/>
+  </p:clrMapOvr>
+</p:sld>
+</file>
+
+<file path=ppt/slides/slide7.xml><?xml version="1.0" encoding="utf-8"?>
 <p:sld xmlns:a="http://schemas.openxmlformats.org/drawingml/2006/main" xmlns:r="http://schemas.openxmlformats.org/officeDocument/2006/relationships" xmlns:p="http://schemas.openxmlformats.org/presentationml/2006/main">
   <p:cSld>
     <p:spTree>
@@ -4513,7 +6933,7 @@
 </p:sld>
 </file>
 
-<file path=ppt/slides/slide6.xml><?xml version="1.0" encoding="utf-8"?>
+<file path=ppt/slides/slide8.xml><?xml version="1.0" encoding="utf-8"?>
 <p:sld xmlns:a="http://schemas.openxmlformats.org/drawingml/2006/main" xmlns:r="http://schemas.openxmlformats.org/officeDocument/2006/relationships" xmlns:p="http://schemas.openxmlformats.org/presentationml/2006/main">
   <p:cSld>
     <p:spTree>
@@ -4654,7 +7074,7 @@
 </p:sld>
 </file>
 
-<file path=ppt/slides/slide7.xml><?xml version="1.0" encoding="utf-8"?>
+<file path=ppt/slides/slide9.xml><?xml version="1.0" encoding="utf-8"?>
 <p:sld xmlns:a="http://schemas.openxmlformats.org/drawingml/2006/main" xmlns:r="http://schemas.openxmlformats.org/officeDocument/2006/relationships" xmlns:p="http://schemas.openxmlformats.org/presentationml/2006/main">
   <p:cSld>
     <p:spTree>
@@ -4662,7 +7082,7 @@
         <p:cNvPr id="1" name="">
           <a:extLst>
             <a:ext uri="{FF2B5EF4-FFF2-40B4-BE49-F238E27FC236}">
-              <a16:creationId xmlns:a16="http://schemas.microsoft.com/office/drawing/2014/main" id="{BDA5B342-9FE5-CEA2-A631-A99D5B8CFDED}"/>
+              <a16:creationId xmlns:a16="http://schemas.microsoft.com/office/drawing/2014/main" id="{1267C277-F776-89B8-959A-BE6A04F5E8C6}"/>
             </a:ext>
           </a:extLst>
         </p:cNvPr>
@@ -4682,7 +7102,7 @@
           <p:cNvPr id="3" name="Title 2">
             <a:extLst>
               <a:ext uri="{FF2B5EF4-FFF2-40B4-BE49-F238E27FC236}">
-                <a16:creationId xmlns:a16="http://schemas.microsoft.com/office/drawing/2014/main" id="{7B049716-59C0-2FB1-72BE-923CF75EB2BC}"/>
+                <a16:creationId xmlns:a16="http://schemas.microsoft.com/office/drawing/2014/main" id="{7F591940-558B-7025-B9BC-AF5E2A44B4AE}"/>
               </a:ext>
             </a:extLst>
           </p:cNvPr>
@@ -4705,7 +7125,7 @@
           <a:p>
             <a:r>
               <a:rPr lang="en-US" dirty="0"/>
-              <a:t>Changes to VTP Connections</a:t>
+              <a:t>Minimum Regression Examples</a:t>
             </a:r>
           </a:p>
         </p:txBody>
@@ -4715,7 +7135,7 @@
           <p:cNvPr id="4" name="Text Placeholder 3">
             <a:extLst>
               <a:ext uri="{FF2B5EF4-FFF2-40B4-BE49-F238E27FC236}">
-                <a16:creationId xmlns:a16="http://schemas.microsoft.com/office/drawing/2014/main" id="{2D8E3E7E-EB71-312D-B9BE-AE329CB4153E}"/>
+                <a16:creationId xmlns:a16="http://schemas.microsoft.com/office/drawing/2014/main" id="{55DF458D-F283-8999-1697-F9D20E3FB2AB}"/>
               </a:ext>
             </a:extLst>
           </p:cNvPr>
@@ -4729,7 +7149,7 @@
         <p:spPr>
           <a:xfrm>
             <a:off x="0" y="1509713"/>
-            <a:ext cx="10625138" cy="4276725"/>
+            <a:ext cx="10625138" cy="3749675"/>
           </a:xfrm>
         </p:spPr>
         <p:txBody>
@@ -4738,53 +7158,92 @@
           <a:p>
             <a:r>
               <a:rPr lang="en-US" sz="2400" dirty="0"/>
-              <a:t>No changes needed in mmd – the mmd doesn’t know there are multiple links</a:t>
-            </a:r>
-          </a:p>
-          <a:p>
-            <a:r>
-              <a:rPr lang="en-US" sz="2400" dirty="0"/>
-              <a:t>The host-memory space is common across both of the PCIe interfaces, which means we can use a single VTP-service block on the parent MMIO link</a:t>
-            </a:r>
-          </a:p>
-          <a:p>
-            <a:r>
-              <a:rPr lang="en-US" sz="2400" dirty="0"/>
-              <a:t>Add new VTP-translation modules for the new links</a:t>
+              <a:t>I typically compile and test the following designs in hardware:</a:t>
             </a:r>
           </a:p>
           <a:p>
             <a:pPr lvl="1"/>
             <a:r>
-              <a:rPr lang="en-US" dirty="0"/>
-              <a:t>Increase the number of </a:t>
-            </a:r>
-            <a:r>
-              <a:rPr lang="en-US" dirty="0" err="1"/>
-              <a:t>vtp_port</a:t>
-            </a:r>
-            <a:r>
-              <a:rPr lang="en-US" dirty="0"/>
-              <a:t> interfaces such that each DMA and USM VTP-translation module has 2 ports</a:t>
-            </a:r>
-          </a:p>
-          <a:p>
-            <a:r>
-              <a:rPr lang="en-US" sz="2400" dirty="0"/>
-              <a:t>Link 0 (the parent link) will carry the same traffic it used to carry</a:t>
+              <a:rPr lang="en-US" sz="2000" dirty="0" err="1"/>
+              <a:t>Aocl</a:t>
+            </a:r>
+            <a:r>
+              <a:rPr lang="en-US" sz="2000" dirty="0"/>
+              <a:t> diagnose and </a:t>
+            </a:r>
+            <a:r>
+              <a:rPr lang="en-US" sz="2000" dirty="0" err="1"/>
+              <a:t>aocl</a:t>
+            </a:r>
+            <a:r>
+              <a:rPr lang="en-US" sz="2000" dirty="0"/>
+              <a:t> diagnose all</a:t>
             </a:r>
           </a:p>
           <a:p>
             <a:pPr lvl="1"/>
             <a:r>
-              <a:rPr lang="en-US" dirty="0"/>
-              <a:t>Normal MMIO transactions, DMA[0] and USM[0] traffic, VTP services</a:t>
-            </a:r>
-          </a:p>
-          <a:p>
-            <a:r>
-              <a:rPr lang="en-US" sz="2400" dirty="0"/>
-              <a:t>Link 1 (the child link) will only carry DMA[1] and USM[1] traffic (and a very basic child-DFH response)</a:t>
+              <a:rPr lang="en-US" sz="2000" dirty="0" err="1"/>
+              <a:t>Anr</a:t>
+            </a:r>
+            <a:r>
+              <a:rPr lang="en-US" sz="2000" dirty="0"/>
+              <a:t> (quick)</a:t>
+            </a:r>
+          </a:p>
+          <a:p>
+            <a:pPr lvl="1"/>
+            <a:r>
+              <a:rPr lang="en-US" sz="2000" dirty="0"/>
+              <a:t>Cholesky and </a:t>
+            </a:r>
+            <a:r>
+              <a:rPr lang="en-US" sz="2000" dirty="0" err="1"/>
+              <a:t>Cholesky_inversion</a:t>
+            </a:r>
+            <a:r>
+              <a:rPr lang="en-US" sz="2000" dirty="0"/>
+              <a:t> (one of them uses read-after-write flow-control which tests the write-ack handling in the ASP)</a:t>
+            </a:r>
+          </a:p>
+          <a:p>
+            <a:pPr lvl="1"/>
+            <a:r>
+              <a:rPr lang="en-US" sz="2000" dirty="0"/>
+              <a:t>Double-buffering (stresses DMA and DDR traffic)</a:t>
+            </a:r>
+          </a:p>
+          <a:p>
+            <a:pPr lvl="1"/>
+            <a:r>
+              <a:rPr lang="en-US" sz="2000" dirty="0"/>
+              <a:t>Simple-host-streaming, buffered-host-</a:t>
+            </a:r>
+            <a:r>
+              <a:rPr lang="en-US" sz="2000" dirty="0" err="1"/>
+              <a:t>streaming,explicit</a:t>
+            </a:r>
+            <a:r>
+              <a:rPr lang="en-US" sz="2000" dirty="0"/>
+              <a:t>-data-movement (USM tests)</a:t>
+            </a:r>
+          </a:p>
+          <a:p>
+            <a:pPr lvl="1"/>
+            <a:r>
+              <a:rPr lang="en-US" sz="2000" dirty="0"/>
+              <a:t>Zero-copy-data-transfer (DMA and USM test, including mixed-size transfers; also supports configurable amount of data at the command-line which allows for weird sizes and corner cases)</a:t>
+            </a:r>
+          </a:p>
+          <a:p>
+            <a:pPr lvl="1"/>
+            <a:r>
+              <a:rPr lang="en-US" sz="2000" dirty="0" err="1"/>
+              <a:t>Boardtest</a:t>
+            </a:r>
+            <a:r>
+              <a:rPr lang="en-US" sz="2000" dirty="0"/>
+              <a:t> (both USM and non-USM variants)</a:t>
             </a:r>
           </a:p>
         </p:txBody>
@@ -4792,249 +7251,7 @@
     </p:spTree>
     <p:extLst>
       <p:ext uri="{BB962C8B-B14F-4D97-AF65-F5344CB8AC3E}">
-        <p14:creationId xmlns:p14="http://schemas.microsoft.com/office/powerpoint/2010/main" val="3906631731"/>
-      </p:ext>
-    </p:extLst>
-  </p:cSld>
-  <p:clrMapOvr>
-    <a:masterClrMapping/>
-  </p:clrMapOvr>
-</p:sld>
-</file>
-
-<file path=ppt/slides/slide8.xml><?xml version="1.0" encoding="utf-8"?>
-<p:sld xmlns:a="http://schemas.openxmlformats.org/drawingml/2006/main" xmlns:r="http://schemas.openxmlformats.org/officeDocument/2006/relationships" xmlns:p="http://schemas.openxmlformats.org/presentationml/2006/main">
-  <p:cSld>
-    <p:spTree>
-      <p:nvGrpSpPr>
-        <p:cNvPr id="1" name="">
-          <a:extLst>
-            <a:ext uri="{FF2B5EF4-FFF2-40B4-BE49-F238E27FC236}">
-              <a16:creationId xmlns:a16="http://schemas.microsoft.com/office/drawing/2014/main" id="{A2DF88FE-9845-CA7D-3358-B2E145EEBA94}"/>
-            </a:ext>
-          </a:extLst>
-        </p:cNvPr>
-        <p:cNvGrpSpPr/>
-        <p:nvPr/>
-      </p:nvGrpSpPr>
-      <p:grpSpPr>
-        <a:xfrm>
-          <a:off x="0" y="0"/>
-          <a:ext cx="0" cy="0"/>
-          <a:chOff x="0" y="0"/>
-          <a:chExt cx="0" cy="0"/>
-        </a:xfrm>
-      </p:grpSpPr>
-      <p:sp>
-        <p:nvSpPr>
-          <p:cNvPr id="3" name="Title 2">
-            <a:extLst>
-              <a:ext uri="{FF2B5EF4-FFF2-40B4-BE49-F238E27FC236}">
-                <a16:creationId xmlns:a16="http://schemas.microsoft.com/office/drawing/2014/main" id="{ED34024D-598E-79B7-6B37-059905D4DB8F}"/>
-              </a:ext>
-            </a:extLst>
-          </p:cNvPr>
-          <p:cNvSpPr>
-            <a:spLocks noGrp="1"/>
-          </p:cNvSpPr>
-          <p:nvPr>
-            <p:ph type="title" idx="4294967295"/>
-          </p:nvPr>
-        </p:nvSpPr>
-        <p:spPr>
-          <a:xfrm>
-            <a:off x="280086" y="234950"/>
-            <a:ext cx="11911914" cy="1200150"/>
-          </a:xfrm>
-        </p:spPr>
-        <p:txBody>
-          <a:bodyPr/>
-          <a:lstStyle/>
-          <a:p>
-            <a:r>
-              <a:rPr lang="en-US" dirty="0"/>
-              <a:t>Changes to AXI/AVMM Conversion </a:t>
-            </a:r>
-            <a:r>
-              <a:rPr lang="en-US"/>
-              <a:t>(PIM Modules)</a:t>
-            </a:r>
-            <a:endParaRPr lang="en-US" dirty="0"/>
-          </a:p>
-        </p:txBody>
-      </p:sp>
-      <p:sp>
-        <p:nvSpPr>
-          <p:cNvPr id="4" name="Text Placeholder 3">
-            <a:extLst>
-              <a:ext uri="{FF2B5EF4-FFF2-40B4-BE49-F238E27FC236}">
-                <a16:creationId xmlns:a16="http://schemas.microsoft.com/office/drawing/2014/main" id="{0AB38191-01E7-ADCA-1EE0-899B77DEBA47}"/>
-              </a:ext>
-            </a:extLst>
-          </p:cNvPr>
-          <p:cNvSpPr>
-            <a:spLocks noGrp="1"/>
-          </p:cNvSpPr>
-          <p:nvPr>
-            <p:ph type="body" idx="4294967295"/>
-          </p:nvPr>
-        </p:nvSpPr>
-        <p:spPr>
-          <a:xfrm>
-            <a:off x="0" y="1509713"/>
-            <a:ext cx="10625138" cy="4276725"/>
-          </a:xfrm>
-        </p:spPr>
-        <p:txBody>
-          <a:bodyPr>
-            <a:normAutofit fontScale="92500"/>
-          </a:bodyPr>
-          <a:lstStyle/>
-          <a:p>
-            <a:r>
-              <a:rPr lang="en-US" dirty="0"/>
-              <a:t>The Parent link remains the same – AXI-ST[0]</a:t>
-            </a:r>
-          </a:p>
-          <a:p>
-            <a:pPr lvl="1"/>
-            <a:r>
-              <a:rPr lang="en-US" dirty="0"/>
-              <a:t>Leverages the PIM’s </a:t>
-            </a:r>
-            <a:r>
-              <a:rPr lang="en-US" dirty="0" err="1"/>
-              <a:t>ofs_plat_host_chan_as_avalon_mem_rdwr_with_mmio</a:t>
-            </a:r>
-            <a:r>
-              <a:rPr lang="en-US" dirty="0"/>
-              <a:t> module to give us the host-mem AVMM_RDWR interface and a MMIO64 AVMM interface for the ASP</a:t>
-            </a:r>
-          </a:p>
-          <a:p>
-            <a:pPr lvl="1"/>
-            <a:r>
-              <a:rPr lang="en-US" dirty="0"/>
-              <a:t>This link’s AFU ID / DFL information changes to indicate there is a child link, including the child’s GUID</a:t>
-            </a:r>
-          </a:p>
-          <a:p>
-            <a:r>
-              <a:rPr lang="en-US" dirty="0"/>
-              <a:t>The Child AXI-ST link is AXI-ST[1]</a:t>
-            </a:r>
-          </a:p>
-          <a:p>
-            <a:pPr lvl="1"/>
-            <a:r>
-              <a:rPr lang="en-US" dirty="0"/>
-              <a:t>Uses the PIM’s </a:t>
-            </a:r>
-            <a:r>
-              <a:rPr lang="en-US" dirty="0" err="1"/>
-              <a:t>ofs_plat_host_chan_fim_multi_link_afu_dfh</a:t>
-            </a:r>
-            <a:r>
-              <a:rPr lang="en-US" dirty="0"/>
-              <a:t> with the child’s GUID</a:t>
-            </a:r>
-          </a:p>
-          <a:p>
-            <a:pPr lvl="1"/>
-            <a:r>
-              <a:rPr lang="en-US" dirty="0"/>
-              <a:t>The PIM’s AXI-ST / AVMM_RDWR conversion occurs using </a:t>
-            </a:r>
-            <a:r>
-              <a:rPr lang="en-US" dirty="0" err="1"/>
-              <a:t>ofs_plat_host_chan_as_avalon_mem_rdwr</a:t>
-            </a:r>
-            <a:r>
-              <a:rPr lang="en-US" dirty="0"/>
-              <a:t>, which is similar to the parent link except it doesn’t include the MMIO AVMM interface (the only MMIO transactions handled on the child link are the DFH transactions)</a:t>
-            </a:r>
-          </a:p>
-          <a:p>
-            <a:endParaRPr lang="en-US" sz="2400" dirty="0"/>
-          </a:p>
-        </p:txBody>
-      </p:sp>
-    </p:spTree>
-    <p:extLst>
-      <p:ext uri="{BB962C8B-B14F-4D97-AF65-F5344CB8AC3E}">
-        <p14:creationId xmlns:p14="http://schemas.microsoft.com/office/powerpoint/2010/main" val="2364973407"/>
-      </p:ext>
-    </p:extLst>
-  </p:cSld>
-  <p:clrMapOvr>
-    <a:masterClrMapping/>
-  </p:clrMapOvr>
-</p:sld>
-</file>
-
-<file path=ppt/slides/slide9.xml><?xml version="1.0" encoding="utf-8"?>
-<p:sld xmlns:a="http://schemas.openxmlformats.org/drawingml/2006/main" xmlns:r="http://schemas.openxmlformats.org/officeDocument/2006/relationships" xmlns:p="http://schemas.openxmlformats.org/presentationml/2006/main">
-  <p:cSld>
-    <p:spTree>
-      <p:nvGrpSpPr>
-        <p:cNvPr id="1" name="">
-          <a:extLst>
-            <a:ext uri="{FF2B5EF4-FFF2-40B4-BE49-F238E27FC236}">
-              <a16:creationId xmlns:a16="http://schemas.microsoft.com/office/drawing/2014/main" id="{DBFA31EC-91F5-2C4A-68DF-9DF2CAD5357F}"/>
-            </a:ext>
-          </a:extLst>
-        </p:cNvPr>
-        <p:cNvGrpSpPr/>
-        <p:nvPr/>
-      </p:nvGrpSpPr>
-      <p:grpSpPr>
-        <a:xfrm>
-          <a:off x="0" y="0"/>
-          <a:ext cx="0" cy="0"/>
-          <a:chOff x="0" y="0"/>
-          <a:chExt cx="0" cy="0"/>
-        </a:xfrm>
-      </p:grpSpPr>
-      <p:pic>
-        <p:nvPicPr>
-          <p:cNvPr id="5" name="Picture 4" descr="A diagram of a flowchart&#10;&#10;Description automatically generated">
-            <a:extLst>
-              <a:ext uri="{FF2B5EF4-FFF2-40B4-BE49-F238E27FC236}">
-                <a16:creationId xmlns:a16="http://schemas.microsoft.com/office/drawing/2014/main" id="{0BE1D7D3-7C5A-6709-4DFF-EB93E63E3D60}"/>
-              </a:ext>
-            </a:extLst>
-          </p:cNvPr>
-          <p:cNvPicPr>
-            <a:picLocks noChangeAspect="1"/>
-          </p:cNvPicPr>
-          <p:nvPr/>
-        </p:nvPicPr>
-        <p:blipFill>
-          <a:blip r:embed="rId2">
-            <a:extLst>
-              <a:ext uri="{28A0092B-C50C-407E-A947-70E740481C1C}">
-                <a14:useLocalDpi xmlns:a14="http://schemas.microsoft.com/office/drawing/2010/main" val="0"/>
-              </a:ext>
-            </a:extLst>
-          </a:blip>
-          <a:stretch>
-            <a:fillRect/>
-          </a:stretch>
-        </p:blipFill>
-        <p:spPr>
-          <a:xfrm>
-            <a:off x="1589" y="295207"/>
-            <a:ext cx="12188825" cy="6105594"/>
-          </a:xfrm>
-          <a:prstGeom prst="rect">
-            <a:avLst/>
-          </a:prstGeom>
-        </p:spPr>
-      </p:pic>
-    </p:spTree>
-    <p:extLst>
-      <p:ext uri="{BB962C8B-B14F-4D97-AF65-F5344CB8AC3E}">
-        <p14:creationId xmlns:p14="http://schemas.microsoft.com/office/powerpoint/2010/main" val="612669385"/>
+        <p14:creationId xmlns:p14="http://schemas.microsoft.com/office/powerpoint/2010/main" val="3008428753"/>
       </p:ext>
     </p:extLst>
   </p:cSld>

</xml_diff>